<commit_message>
Deck for 10-12: paper's method names and terms; notes read numbers from gen/
- Same glossary as the paper (失效, 检查结果, 同快照验证, 先检查后执行,
  定义库回放, 按模式变更失效, 检查结果缓存, 状态变更行, 多版本更正, 缓慢变化维 ...).
- Speaker notes and titles that hard-coded 73%, 645, 16 points, 342 now read
  the macros, so they follow the agent-SQL MAVRA (74%, 629, 17 points).
- Appendix A2 compares MAVRA (agent's own SQL) with MAVRA (gold SQL).
- Source list points at figures/scenario-changes.tex (tables/scenarios.tex was
  replaced by a figure in 450536b, which had broken the build).

Co-Authored-By: Claude Opus 5.5 <noreply@anthropic.com>
</commit_message>
<xml_diff>
--- a/docs/mavra-report-2026-10-12.pptx
+++ b/docs/mavra-report-2026-10-12.pptx
@@ -203,7 +203,7 @@
                     <c:v>仅缩小范围</c:v>
                   </c:pt>
                   <c:pt idx="2">
-                    <c:v>通用缓存</c:v>
+                    <c:v>检查结果缓存</c:v>
                   </c:pt>
                   <c:pt idx="3">
                     <c:v>MAVRA</c:v>
@@ -459,10 +459,10 @@
                     <c:v>轨迹检索</c:v>
                   </c:pt>
                   <c:pt idx="2">
-                    <c:v>检索 + 自验证</c:v>
+                    <c:v>检索 + 自检</c:v>
                   </c:pt>
                   <c:pt idx="3">
-                    <c:v>共享不维护</c:v>
+                    <c:v>共享不验证</c:v>
                   </c:pt>
                   <c:pt idx="4">
                     <c:v>MAVRA</c:v>
@@ -554,10 +554,10 @@
                     <c:v>轨迹检索</c:v>
                   </c:pt>
                   <c:pt idx="2">
-                    <c:v>检索 + 自验证</c:v>
+                    <c:v>检索 + 自检</c:v>
                   </c:pt>
                   <c:pt idx="3">
-                    <c:v>共享不维护</c:v>
+                    <c:v>共享不验证</c:v>
                   </c:pt>
                   <c:pt idx="4">
                     <c:v>MAVRA</c:v>
@@ -585,7 +585,7 @@
                   <c:v>59</c:v>
                 </c:pt>
                 <c:pt idx="4">
-                  <c:v>73</c:v>
+                  <c:v>74</c:v>
                 </c:pt>
               </c:numCache>
             </c:numRef>
@@ -784,7 +784,7 @@
               <c:strCache>
                 <c:ptCount val="1"/>
                 <c:pt idx="0">
-                  <c:v>通用版本缓存</c:v>
+                  <c:v>检查结果缓存</c:v>
                 </c:pt>
               </c:strCache>
             </c:strRef>
@@ -1508,7 +1508,7 @@
           <a:p>
             <a:r>
               <a:rPr lang="en-US" dirty="0"/>
-              <a:t>开场一句话：数据智能体会把“业务指标怎么算”自己摸索出来，并把结果共享给后面的会话；数据一变，这些共享的 SQL 可能悄悄算错。我们做的事是让数据库替智能体记住“这个定义为什么成立”，数据变了就重新核对，用的时候只在核对通过的数据上执行，坏了谨慎修或撤下。今天先讲背景和问题，再讲做法和实验，最后是进展和想讨论的问题。
+              <a:t>开场一句话：数据智能体会把“业务指标怎么算”自己摸索出来，并把结果共享给后面的会话；数据一变，这些共享的 SQL 可能悄悄算错。我们做的事是让数据库替智能体记住“这个定义为什么成立”，数据变了就重新核对，用的时候只在核对通过的数据上执行，坏了谨慎修，修不了就让它失效。今天先讲背景和问题，再讲做法和实验，最后是进展和想讨论的问题。
 依据：论文标题 / 摘要
 报告日期：2026-10-12。内容对应当前 overleaf/ 正文；归档结果单独标注。</a:t>
             </a:r>
@@ -1598,7 +1598,7 @@
           <a:p>
             <a:r>
               <a:rPr lang="en-US" dirty="0"/>
-              <a:t>条件的检查结论按“条件身份 + 它读的那些表的版本”索引。表没变，结论继续有效；表变了，只有读到这张表的条件需要重查，而且一个条件的结论被所有依赖它的口径和智能体共享。右边是受控实验里的一个例子：更新 store_returns 后，有 8 个口径受影响；逐个口径重查要跑 19 次检查，但其实只涉及 3 个不同的条件。TPC-DS 的 99 个官方模板里共享更明显。要诚实地说：这种节省大部分用一个按版本索引的检查缓存也能拿到，所以论文不把它当主要贡献。
+              <a:t>条件的检查结果按“条件的规范形式 + 它读的那些表的版本”索引。表没变，检查结果继续有效；表变了，只有读到这张表的条件需要重查，而且一个条件的检查结果被所有依赖它的口径和智能体共享。右边是受控实验里的一个例子：更新 store_returns 后，有 8 个口径受影响；逐个口径重查要跑 19 次检查，但其实只涉及 3 个不同的条件。TPC-DS 的 99 个官方模板里共享更明显。要诚实地说：这种节省大部分用一个按版本索引的检查缓存也能拿到，所以论文不把它当主要贡献。
 依据：论文 §4.4、§5.2；gen/review.tex
 报告日期：2026-10-12。内容对应当前 overleaf/ 正文；归档结果单独标注。</a:t>
             </a:r>
@@ -1688,8 +1688,8 @@
           <a:p>
             <a:r>
               <a:rPr lang="en-US" dirty="0"/>
-              <a:t>上面一行是常见做法：先检查，通过后再执行查询。问题是两步之间可能有写入提交，查询读到的已经是新数据，检查结论对它不成立——我们的并发实验里这种情况占 3.8% 到 4.6%。下面一行是我们的做法：把检查和查询放进同一个可重复读事务，读同一个快照；别处算好的结论只有在依赖表的事务性版本完全相同时才复用，这就是引理 1。要说明一点：默认的 DML 统计是异步更新的，统计值相同不代表数据相同，所以这个保证需要事务性版本（由写事务内的触发器维护）。
-依据：论文 §6.2；引理 1；绑定快照为可选模式
+              <a:t>上面一行是常见做法：先检查，通过后再执行查询。问题是两步之间可能有写入提交，查询读到的已经是新数据，检查结果对它不成立——我们的并发实验里这种情况占 3.8% 到 4.6%。下面一行是我们的做法：把检查和查询放进同一个可重复读事务，读同一个快照；别处算好的检查结果只有在依赖表的事务性版本完全相同时才复用，这就是引理 1。要说明一点：默认的 DML 统计是异步更新的，统计值相同不代表数据相同，所以这个保证需要事务性版本（由写事务内的触发器维护）。
+依据：论文 §6.2；引理 1；同快照验证为可选模式
 报告日期：2026-10-12。内容对应当前 overleaf/ 正文；归档结果单独标注。</a:t>
             </a:r>
             <a:endParaRPr lang="en-US" dirty="0"/>
@@ -1778,7 +1778,7 @@
           <a:p>
             <a:r>
               <a:rPr lang="en-US" dirty="0"/>
-              <a:t>条件不成立时，有两种结局：修好，或撤下。修复只做一件事：在低基数列上找一个等值过滤。三道关：过滤后要恢复“一键一行”而且不丢任何业务键；候选过滤必须恰好一个；再通过准入门槛和用学习题做的回归测试。用两个例子说明为什么要“唯一”：状态流水的例子里，“状态=完成”是唯一能恢复粒度的过滤，修复成功；备份副本的例子里，“来源=主库”和“来源=备份”都能恢复粒度，结构上分不出哪个是真实业务数据，所以撤下。宁可不可用，也不发布可能错的修复。
+              <a:t>条件不成立时，有两种结局：修好，或让它失效。修复只做一件事：在低基数列上找一个等值过滤。三道关：过滤后要恢复“一键一行”而且不丢任何业务键；候选过滤必须恰好一个；再通过准入检查和用学习题做的回归测试。用两个例子说明为什么要“唯一”：状态变更行的例子里，“状态=完成”是唯一能恢复粒度的过滤，修复成功；备份副本的例子里，“来源=主库”和“来源=备份”都能恢复粒度，结构上分不出哪个是真实业务数据，所以让它失效。宁可不可用，也不发布可能错的修复。
 依据：论文 §5.3；算法 1；§7.4
 报告日期：2026-10-12。内容对应当前 overleaf/ 正文；归档结果单独标注。</a:t>
             </a:r>
@@ -1868,7 +1868,7 @@
           <a:p>
             <a:r>
               <a:rPr lang="en-US" dirty="0"/>
-              <a:t>系统是一个 HTTP 中间层，智能体通过它的工具接口访问数据库。三条路径：准入——判题成功的学习轨迹被提炼成结构化口径，通过七道门槛后发布；维护——依赖的表版本变了就按条件重查、复用结论、撤销或修复；执行——智能体在 run_sql 里声明用到的口径和修订号，中间层核对修订、审查 SQL，并在绑定快照模式下在同一事务里验证和执行。版本来源有两种：默认的表指纹加 DML 统计，和由语句级触发器维护的事务性版本。
+              <a:t>系统是一个 HTTP 中间件，智能体通过它的工具接口访问数据库。三条路径：准入——判题成功的学习轨迹被提取成结构化口径，通过七项准入检查后发布；维护——依赖的表版本变了就按条件重查、复用检查结果、置为失效或修复；执行——智能体在 run_sql 里声明用到的口径和修订号，中间件核对修订、审查 SQL，并在同快照模式下在同一事务里验证和执行。版本来源有两种：默认的表指纹加 DML 统计，和由语句级触发器维护的事务性版本。
 依据：论文 §3；约 6,600 行 Rust，40 个测试
 报告日期：2026-10-12。内容对应当前 overleaf/ 正文；归档结果单独标注。</a:t>
             </a:r>
@@ -1958,7 +1958,7 @@
           <a:p>
             <a:r>
               <a:rPr lang="en-US" dirty="0"/>
-              <a:t>实验分两层，这样能把“维护机制对不对”和“智能体学得好不好”分开。机制层固定口径和数据变化，只替换维护方式：配对回放（3 个大模型学到的 15 个口径库，加上从 TPC-DS 99 个官方模板导出的库，各经历 11 种数据变化）、并发写入、维护代价（100 万到 1600 万行）。端到端层用 DeepSeek V4.1 Flash 跑完整智能体：5 个指标，先学再用，11 种数据变化，9 种方法各独立跑 3 次，共 2586 道计分题；另有 216 个固定口径库的完整会话用来量任务时间和 token。右边列出 11 种数据变化是什么，其中单位换算是条件看不到的对照。
+              <a:t>实验分两层，这样能把“维护机制对不对”和“智能体学得好不好”分开。系统层固定口径和数据变化，只替换维护方式：定义库回放（3 个大模型学到的 15 个口径库，加上从 TPC-DS 99 个官方模板导出的库，各经历 11 种数据变化）、并发写入、维护代价（100 万到 1600 万行）。端到端层用 DeepSeek V4.1 Flash 跑完整智能体：5 个指标，先学再用，11 种数据变化，9 种方法各独立跑 3 次，共 2586 道计分题；另有 216 个固定口径库的完整会话用来量任务时间和 token。右边列出 11 种数据变化是什么，其中单位换算是条件看不到的对照。
 依据：论文 §7.1；表 2、表 3
 报告日期：2026-10-12。内容对应当前 overleaf/ 正文；归档结果单独标注。</a:t>
             </a:r>
@@ -2048,8 +2048,8 @@
           <a:p>
             <a:r>
               <a:rPr lang="en-US" dirty="0"/>
-              <a:t>配对回放把同一个口径库放在不同维护方式下经历同样的变化，所以差异只来自维护。在条件能发现的变化下，MAVRA 没有给出任何错误答案，只看结构的维护给出 645 个；真实 TPC-DS 数据上是 0 对 437。dbt 式的表级测试也能把破坏隔离，但不会修，少答对 342 题。条件级、定义级和通用缓存三种重验方式逐题答案完全一样，说明端到端里它们的差异来自学到的库而不是维护。表里的 101 个错误全部来自单位换算这个对照，它不违反任何条件，论文明确把它划在边界之外。
-依据：论文 §7.2；gen/review.tex；表 4
+              <a:t>定义库回放把同一个口径库放在不同维护方式下经历同样的变化，所以差异只来自维护；所有方法都用智能体自己的学习 SQL 作回归对照。在条件能发现的变化下，MAVRA 没有给出任何错误答案，按模式变更失效给出 629 个；真实 TPC-DS 数据上是 0 对 437。dbt 式的表级测试也能让被破坏的口径失效，但不会修，少答对 177 题。条件级、定义级和检查结果缓存三种重验方式逐题答案完全一样，说明端到端里它们的差异来自学到的库而不是维护。图里的 99 个错误全部来自单位换算这个对照，它不违反任何条件，论文明确把它划在边界之外。
+依据：论文 §7.2；gen/review.tex；图 4
 报告日期：2026-10-12。内容对应当前 overleaf/ 正文；归档结果单独标注。</a:t>
             </a:r>
             <a:endParaRPr lang="en-US" dirty="0"/>
@@ -2138,7 +2138,7 @@
           <a:p>
             <a:r>
               <a:rPr lang="en-US" dirty="0"/>
-              <a:t>随机交错的并发实验：一边有写入者反复装载重复数据，一边有读者声明口径查询。执行前检查在没有通知的写入下有 3.8% 到 4.6% 的作答落在违反条件的数据上；绑定快照执行在 11,297 次作答里一次也没有。读者的中位延迟两种模式一样，因为快照模式复用了维护阶段的结论。代价在写入者这边：每条写语句多一次计数器更新，单写者吞吐是无触发器的 0.70 倍，32 个并发写者分片计数后 0.97 倍，不分片会掉到 0.36 倍。
+              <a:t>随机交错的并发实验：一边有写入者反复装载重复数据，一边有读者声明口径查询。先检查后执行在没有通知的写入下有 3.8% 到 4.6% 的作答落在违反条件的数据上；同快照验证在 11,297 次作答里一次也没有。读者的中位延迟两种模式一样，因为快照模式复用了维护阶段的检查结果。代价在写入者这边：每条写语句多一次计数器更新，单写者吞吐是无触发器的 0.70 倍，32 个并发写者分片计数后 0.97 倍，不分片会掉到 0.36 倍。
 依据：论文 §7.3；gen/review.tex；表 5
 报告日期：2026-10-12。内容对应当前 overleaf/ 正文；归档结果单独标注。</a:t>
             </a:r>
@@ -2228,7 +2228,7 @@
           <a:p>
             <a:r>
               <a:rPr lang="en-US" dirty="0"/>
-              <a:t>受控实验里，19 个口径共享条件，8 个脚本智能体错峰使用。把逐口径重查全部条件的“定义级”记为 100%：只缩小范围不复用结论是 86.8%，按 SQL 文本和版本缓存检查结果的通用缓存是 16.7%，MAVRA 是 14.0%。两点要如实讲：一是节省来自结论共享，通用缓存几乎拿到同样的节省，所以这不是论文的主要贡献；二是比例从 100 万行到 1600 万行都稳定在 12% 到 13%。
+              <a:t>受控实验里，19 个口径共享条件，8 个脚本智能体错峰使用。把逐口径重查全部条件的“定义级”记为 100%：只缩小范围不复用检查结果是 86.8%，按 SQL 文本和版本缓存检查结果的检查结果缓存是 16.7%，MAVRA 是 14.0%。两点要如实讲：一是节省来自检查结果共享，检查结果缓存几乎拿到同样的节省，所以这不是论文的主要贡献；二是比例从 100 万行到 1600 万行都稳定在 12% 到 13%。
 依据：论文 §7.5；gen/review.tex；19 个口径、错峰到达
 报告日期：2026-10-12。内容对应当前 overleaf/ 正文；归档结果单独标注。</a:t>
             </a:r>
@@ -2318,7 +2318,7 @@
           <a:p>
             <a:r>
               <a:rPr lang="en-US" dirty="0"/>
-              <a:t>蓝柱是全部情形，橙柱是条件能发现的破坏性变化。先看蓝柱：不共享 32%，共享但不维护 75%，MAVRA 81%，所以共享本身是最大的一步。再看橙柱：破坏性变化下，MAVRA 73%，模仿 AgentSM 的轨迹检索 57%，预先登记的比较差 16 个百分点，95% 区间 14 到 18；让检索的智能体自己检查这些性质，也只到 63%。右下角是一个诚实的反例：备份副本的变化下 MAVRA 撤下了口径，智能体要自己重找，这一组反而输给检索。
+              <a:t>蓝柱是全部情形，橙柱是条件能发现的破坏性变化。先看蓝柱：不共享 32%，共享但不验证 75%，MAVRA 81%，所以共享本身是最大的一步。再看橙柱：破坏性变化下，MAVRA 74%，模仿 AgentSM 的轨迹检索 57%，预先登记的比较差 17 个百分点，95% 区间 15 到 18；让检索的智能体自己检查这些性质，也只到 63%。右下角是一个诚实的反例：备份副本的变化下 MAVRA 让口径失效了，智能体要自己重找，这一组反而输给检索。
 依据：论文 §7.6；gen/scen-ds.tex；9 种方法 × 3 次
 报告日期：2026-10-12。内容对应当前 overleaf/ 正文；归档结果单独标注。</a:t>
             </a:r>
@@ -2408,7 +2408,7 @@
           <a:p>
             <a:r>
               <a:rPr lang="en-US" dirty="0"/>
-              <a:t>两组实验。上面的表是固定口径库的会话实验：每道题一个全新会话，不共享的智能体 54 题只答对 16 题、平均 64 秒；有共享口径的三种方法都 54 题全对，MAVRA 平均 38 秒，输入 token 少 40.7%。要说清楚：这个节省来自共享，定义级和通用缓存也在 32、33 秒，维护方式之间没有延迟优势。下面一行是另一个实验：所有智能体都拿到相同的业务定义、正确率相同，只看探索开销——逐步积累的共享知识把每题的结构查找从 3.5 次减到 2.5 次，SQL 探查从 0.20 次减到 0.06 次。
+              <a:t>两组实验。上面的表是固定口径库的会话实验：每道题一个全新会话，不共享的智能体 54 题只答对 16 题、平均 64 秒；有共享口径的三种方法都 54 题全对，MAVRA 平均 38 秒，输入 token 少 40.7%。要说清楚：这个节省来自共享，定义级和检查结果缓存也在 32、33 秒，维护方式之间没有延迟优势。下面一行是另一个实验：所有智能体都拿到相同的业务定义、正确率相同，只看探索开销——逐步积累的共享知识把每题的结构查找从 3.5 次减到 2.5 次，SQL 探查从 0.20 次减到 0.06 次。
 依据：论文 §7.6；gen/session-latency.tex；exp/2026-10-03-shared-memory/analysis/summary.json
 报告日期：2026-10-12。内容对应当前 overleaf/ 正文；归档结果单独标注。</a:t>
             </a:r>
@@ -2498,7 +2498,7 @@
           <a:p>
             <a:r>
               <a:rPr lang="en-US" dirty="0"/>
-              <a:t>这页是给第一次接触这个方向的听众的地图。四个框按“背景—问题—做法—效果”排列，后面每一节都对应其中一个框。三个数字分别来自三组不同实验，不是同一个分母：73% 对 57% 是真实智能体在破坏性数据变化下的最终答案正确率；0 违规是并发写入下的机制实验；64 秒到 38 秒是固定定义库的会话实验。
+              <a:t>这页是给第一次接触这个方向的听众的地图。四个框按“背景—问题—做法—效果”排列，后面每一节都对应其中一个框。三个数字分别来自三组不同实验，不是同一个分母：74% 对 57% 是真实智能体在破坏性数据变化下的最终答案正确率；0 违规是并发写入下的系统层实验；64 秒到 38 秒是固定定义库的会话实验。
 依据：论文摘要；gen/scen-ds.tex、review.tex、session-latency.tex
 报告日期：2026-10-12。内容对应当前 overleaf/ 正文；归档结果单独标注。</a:t>
             </a:r>
@@ -2588,7 +2588,7 @@
           <a:p>
             <a:r>
               <a:rPr lang="en-US" dirty="0"/>
-              <a:t>主动把边界讲清楚，比被问到再解释好。第一，使用时的保证只覆盖声明了口径的查询：此前样本里 25.7% 的答案没有声明口径；声明了正确修订仍有 1.3% 因为自己写的 SQL 偏离规范计算而答错。第二，四类条件是结构条件，看不到取值语义（单位换算）和两份同样合法的总体（备份副本），这两类需要业务证据。第三，评估的局限：机制层的数据变化是我们注入的，不是真实的更新历史；端到端主实验只有一个模型、每种方法 3 次，更早一轮三个模型的趋势一致。
+              <a:t>主动把边界讲清楚，比被问到再解释好。第一，使用时的保证只覆盖声明了口径的查询：此前样本里 25.7% 的答案没有声明口径；声明了正确修订仍有 1.3% 因为自己写的 SQL 偏离规范计算而答错。第二，四类条件是结构条件，看不到取值语义（单位换算）和两份同样合法的总体（备份副本），这两类需要业务证据。第三，评估的局限：系统层的数据变化是我们注入的，不是真实的更新历史；端到端主实验只有一个模型、每种方法 3 次，更早一轮三个模型的趋势一致。
 依据：论文 §6.3、§7.6、§9
 报告日期：2026-10-12。内容对应当前 overleaf/ 正文；归档结果单独标注。</a:t>
             </a:r>
@@ -2768,7 +2768,7 @@
           <a:p>
             <a:r>
               <a:rPr lang="en-US" dirty="0"/>
-              <a:t>收束回一句话：学到的口径成了长期状态；四类条件说明要查什么，事务性版本和绑定快照说明什么时候可以用，唯一且过回归的修复说明坏了怎么办。最后列出三个想请老师把关的问题：定位是否站得住、评估要补哪一项最有说服力、投稿目标与时间。
+              <a:t>收束回一句话：学到的口径成了长期状态；四类条件说明要查什么，事务性版本和同快照验证说明什么时候可以用，唯一且过回归的修复说明坏了怎么办。最后列出三个想请老师把关的问题：定位是否站得住、评估要补哪一项最有说服力、投稿目标与时间。
 依据：论文 §10
 报告日期：2026-10-12。内容对应当前 overleaf/ 正文；归档结果单独标注。</a:t>
             </a:r>
@@ -2948,7 +2948,7 @@
           <a:p>
             <a:r>
               <a:rPr lang="en-US" dirty="0"/>
-              <a:t>问答备用。同一批 1,470 道配对题，用智能体自己的学习 SQL 作回归参照比用判题参照少答对，但差别全部变成“不可用”，没有新增错误；端到端下两种参照 74% 对 73%。备份副本反例：不要求候选唯一时，一个预见来源列的参照会让错误修复发布，4 道新题错 2 道；要求唯一后两种参照都撤下。修复进行中到达的请求等待结果，同时到达的不可用从 63 降到 0。
+              <a:t>问答备用。MAVRA 用智能体自己的学习 SQL 作回归对照，这是部署中一定有的。换成知道区分列的标准答案 SQL 后，同一批 1,470 道题多答对 153 道，全部是多版本更正和缓慢变化维下被拒绝、因而失效的修复，没有一道题因此答错；端到端下两种配置 74% 对 73%，因为口径失效后智能体会自己重新推出过滤。备份副本反例：不要求候选唯一时，一个预见来源列的参照会让错误修复发布，4 道新题错 2 道；要求唯一后两种参照都让口径失效。修复进行中到达的请求与正在进行的修复合并，同时到达的不可用从 63 降到 0。
 依据：论文 §7.4；gen/review.tex、scen-ds.tex
 报告日期：2026-10-12。内容对应当前 overleaf/ 正文；归档结果单独标注。</a:t>
             </a:r>
@@ -3038,7 +3038,7 @@
           <a:p>
             <a:r>
               <a:rPr lang="en-US" dirty="0"/>
-              <a:t>问答备用。这张表是机制定位，不表示所有行都跑了同一个端到端矩阵：表级测试在配对回放里跑；定义级加缓存在代价实验和固定库会话里跑；端到端场景是 9 种方法。
+              <a:t>问答备用。这张表是机制定位，不表示所有行都跑了同一个端到端矩阵：表级测试在定义库回放里跑；定义级加缓存在代价实验和固定库会话里跑；端到端场景是 9 种方法。
 依据：论文 §2.4、表 3；概念对照
 报告日期：2026-10-12。内容对应当前 overleaf/ 正文；归档结果单独标注。</a:t>
             </a:r>
@@ -3128,7 +3128,7 @@
           <a:p>
             <a:r>
               <a:rPr lang="en-US" dirty="0"/>
-              <a:t>问答备用，也是对“MAVRA 比通用缓存更快吗”的诚实回答：不是。更新后首次使用 MAVRA 更快（追加后 12.53 对 18.00 秒，破坏后 28.41 对 32.01），但突发到达时 78 对 58 秒，一次 356 秒的长尾里 338 秒是模型接口时间。全矩阵平均 37.68 对 31.97 秒；数据库工作量少 25.3% 推不出整体更快。只有 3 个库，描述性结果。
+              <a:t>问答备用，也是对“MAVRA 比检查结果缓存更快吗”的诚实回答：不是。更新后首次使用 MAVRA 更快（追加后 12.53 对 18.00 秒，破坏后 28.41 对 32.01），但突发到达时 78 对 58 秒，一次 356 秒的长尾里 338 秒是模型接口时间。全矩阵平均 37.68 对 31.97 秒；数据库工作量少 25.3% 推不出整体更快。只有 3 个库，描述性结果。
 依据：exp/2026-10-03-session-latency/stats.json、report.md
 报告日期：2026-10-12。内容对应当前 overleaf/ 正文；归档结果单独标注。</a:t>
             </a:r>
@@ -3398,7 +3398,7 @@
           <a:p>
             <a:r>
               <a:rPr lang="en-US" dirty="0"/>
-              <a:t>用退货金额把“口径”讲具体：事实表、度量、粒度、时间角色、过滤。这些东西 SQL 里不写、表结构也不保证，是业务上的约定。右边三个数字说明智能体离不开这类知识：Spider 2.0 的企业级任务上，o1-preview 智能体只完成 21.3%；BIRD 上给 GPT-4 专家标注的业务知识后正确率从 34.9% 升到 54.9%；我们自己的实验里，把学到的口径共享给新会话，正确率从 32% 升到 75%。所以口径要么有人告诉它，要么它自己摸索出来再记住。
+              <a:t>用退货金额把“口径”讲具体：事实表、度量、粒度、日期角色、过滤。这些东西 SQL 里不写、表结构也不保证，是业务上的约定。右边三个数字说明智能体离不开这类知识：Spider 2.0 的企业级任务上，o1-preview 智能体只完成 21.3%；BIRD 上给 GPT-4 专家标注的业务知识后正确率从 34.9% 升到 54.9%；我们自己的实验里，把学到的口径共享给新会话，正确率从 32% 升到 75%。所以口径要么有人告诉它，要么它自己摸索出来再记住。
 依据：论文 §1、§2.2；Spider 2.0、BIRD 的数字取自原论文
 报告日期：2026-10-12。内容对应当前 overleaf/ 正文；归档结果单独标注。</a:t>
             </a:r>
@@ -3668,7 +3668,7 @@
           <a:p>
             <a:r>
               <a:rPr lang="en-US" dirty="0"/>
-              <a:t>听众可能会问：数据库和数据工程不是早有一套工具吗？四条路逐一说明。按表结构跟踪变化：表没变，什么也看不到，回放实验里只看结构的方法给出 645 个错误答案。dbt 式的数据测试：按表测，不知道哪个口径依赖哪条性质，测试一失败只能把整张表上的定义全部隔离，少答对 342 题。指标层：Databricks 的文档明确写了声明的连接性质“不在运行时验证”。让智能体自己查：轨迹里只有 16% 的会话会检查键唯一性；就算提示它去查，破坏性变化下也只从 57% 提到 63%，而由系统维护是 73%。
+              <a:t>听众可能会问：数据库和数据工程不是早有一套工具吗？四条路逐一说明。按表结构跟踪变化：表没变，什么也看不到，回放实验里按模式变更失效给出 629 个错误答案。dbt 式的数据测试：按表测，不知道哪个口径依赖哪条性质，测试一失败只能让整张表上的定义全部失效，少答对 177 题。指标层：Databricks 的文档明确写了声明的连接性质“不在运行时验证”。让智能体自己查：轨迹里只有 16% 的会话会检查键唯一性；就算提示它去查，破坏性变化下也只从 57% 提到 63%，而由系统维护是 74%。
 依据：论文 §1、§2.4、§7.2、§7.6；gen/review.tex、scen-ds.tex
 报告日期：2026-10-12。内容对应当前 overleaf/ 正文；归档结果单独标注。</a:t>
             </a:r>
@@ -3758,7 +3758,7 @@
           <a:p>
             <a:r>
               <a:rPr lang="en-US" dirty="0"/>
-              <a:t>这是整个工作的主线，后面四页分别展开。第一步“记录”：从口径的结构化定义里推出四类可执行条件，就是上一页说的“成立条件”。第二步“维护”：条件的检查结论按数据版本保存；数据更新后只重查被触及的条件，结论在所有依赖它的口径和智能体之间共享。第三步“约束使用”：声明了口径的查询只在条件成立的那份数据快照上执行。第四步“处理失效”：条件不再成立时，只接受唯一且通过回归测试的修复，否则撤下口径，宁可不可用也不给错答案。
+              <a:t>这是整个工作的主线，后面四页分别展开。第一步“记录”：从口径的结构化定义里推出四类可执行条件，就是上一页说的“成立条件”。第二步“维护”：条件的检查结果按数据版本保存；数据更新后只重查被触及的条件，检查结果在所有依赖它的口径和智能体之间共享。第三步“约束使用”：声明了口径的查询只在条件成立的那份数据快照上执行。第四步“处理失效”：条件不再成立时，只接受唯一且通过回归测试的修复，否则让口径失效，宁可不可用也不给错答案。
 依据：论文 §1、§3–§6
 报告日期：2026-10-12。内容对应当前 overleaf/ 正文；归档结果单独标注。</a:t>
             </a:r>
@@ -3848,7 +3848,7 @@
           <a:p>
             <a:r>
               <a:rPr lang="en-US" dirty="0"/>
-              <a:t>每一行先用白话说这个条件在保证什么，再说在退货金额里具体是什么，最后说数据库里怎么查。这四类条件都能写成 SQL 查询，返回“违反的证据”或空。命题 1 是论文的第一项形式化结果：在两条业务前提下（业务事件和过滤后的键一一对应；度量列就是事件的度量），四类条件成立就能保证规范 SQL 把每笔业务事件在它所属的期间恰好算一次，遗漏只限于覆盖条件约束的那部分。命题同时划清了边界：单位换算这类取值变化不违反任何条件，条件看不到。
+              <a:t>每一行先用白话说这个条件在保证什么，再说在退货金额里具体是什么，最后说数据库里怎么查。这四类条件都能写成 SQL 查询，返回“违反的证据”或空。命题 1 是论文的第一项形式化结果：在两条业务前提下（业务事件和过滤后的键一一对应；度量列就是事件的度量），四类条件成立就能保证规范 SQL 把每笔业务事件在它所属的期间恰好算一次，遗漏只限于完整性条件约束的那部分。命题同时划清了边界：单位换算这类取值变化不违反任何条件，条件看不到。
 依据：论文 §4.2、§4.3；命题 1
 报告日期：2026-10-12。内容对应当前 overleaf/ 正文；归档结果单独标注。</a:t>
             </a:r>
@@ -5211,7 +5211,7 @@
                 <a:ea typeface="Microsoft YaHei" pitchFamily="34" charset="-122"/>
                 <a:cs typeface="Microsoft YaHei" pitchFamily="34" charset="-120"/>
               </a:rPr>
-              <a:t>其余条件的结论保留</a:t>
+              <a:t>其余条件的检查结果保留</a:t>
             </a:r>
             <a:endParaRPr lang="en-US" sz="1450" dirty="0"/>
           </a:p>
@@ -5372,7 +5372,7 @@
                 <a:ea typeface="Microsoft YaHei" pitchFamily="34" charset="-122"/>
                 <a:cs typeface="Microsoft YaHei" pitchFamily="34" charset="-120"/>
               </a:rPr>
-              <a:t>重查并保存结论</a:t>
+              <a:t>重查并保存检查结果</a:t>
             </a:r>
             <a:endParaRPr lang="en-US" sz="1700" dirty="0"/>
           </a:p>
@@ -5414,7 +5414,7 @@
                 <a:ea typeface="Microsoft YaHei" pitchFamily="34" charset="-122"/>
                 <a:cs typeface="Microsoft YaHei" pitchFamily="34" charset="-120"/>
               </a:rPr>
-              <a:t>索引 = (条件身份, 依赖表版本)</a:t>
+              <a:t>索引 = (条件的规范形式, 依赖表版本)</a:t>
             </a:r>
             <a:endParaRPr lang="en-US" sz="1450" dirty="0"/>
           </a:p>
@@ -5570,7 +5570,7 @@
                 <a:ea typeface="Microsoft YaHei" pitchFamily="34" charset="-122"/>
                 <a:cs typeface="Microsoft YaHei" pitchFamily="34" charset="-120"/>
               </a:rPr>
-              <a:t>所有口径共享结论</a:t>
+              <a:t>所有口径共享检查结果</a:t>
             </a:r>
             <a:endParaRPr lang="en-US" sz="1700" dirty="0"/>
           </a:p>
@@ -5612,7 +5612,7 @@
                 <a:ea typeface="Microsoft YaHei" pitchFamily="34" charset="-122"/>
                 <a:cs typeface="Microsoft YaHei" pitchFamily="34" charset="-120"/>
               </a:rPr>
-              <a:t>一个结论服务所有需要</a:t>
+              <a:t>一个检查结果服务所有需要</a:t>
             </a:r>
             <a:endParaRPr lang="en-US" sz="1450" dirty="0"/>
           </a:p>
@@ -6159,7 +6159,7 @@
                 <a:ea typeface="Microsoft YaHei" pitchFamily="34" charset="-122"/>
                 <a:cs typeface="Microsoft YaHei" pitchFamily="34" charset="-120"/>
               </a:rPr>
-              <a:t>论文 §6.2；引理 1；绑定快照为可选模式</a:t>
+              <a:t>论文 §6.2；引理 1；同快照验证为可选模式</a:t>
             </a:r>
             <a:endParaRPr lang="en-US" sz="850" dirty="0"/>
           </a:p>
@@ -6243,7 +6243,7 @@
                 <a:ea typeface="Microsoft YaHei" pitchFamily="34" charset="-122"/>
                 <a:cs typeface="Microsoft YaHei" pitchFamily="34" charset="-120"/>
               </a:rPr>
-              <a:t>执行前检查（常见做法）</a:t>
+              <a:t>先检查后执行（常见做法）</a:t>
             </a:r>
             <a:endParaRPr lang="en-US" sz="1500" dirty="0"/>
           </a:p>
@@ -6636,7 +6636,7 @@
                 <a:ea typeface="Microsoft YaHei" pitchFamily="34" charset="-122"/>
                 <a:cs typeface="Microsoft YaHei" pitchFamily="34" charset="-120"/>
               </a:rPr>
-              <a:t>绑定快照执行（MAVRA）</a:t>
+              <a:t>同快照验证（MAVRA）</a:t>
             </a:r>
             <a:endParaRPr lang="en-US" sz="1500" dirty="0"/>
           </a:p>
@@ -6843,7 +6843,7 @@
                 <a:ea typeface="Microsoft YaHei" pitchFamily="34" charset="-122"/>
                 <a:cs typeface="Microsoft YaHei" pitchFamily="34" charset="-120"/>
               </a:rPr>
-              <a:t>引理 1（结论复用）</a:t>
+              <a:t>引理 1（检查结果复用）</a:t>
             </a:r>
             <a:endParaRPr lang="en-US" sz="1700" dirty="0"/>
           </a:p>
@@ -6885,7 +6885,7 @@
                 <a:ea typeface="Microsoft YaHei" pitchFamily="34" charset="-122"/>
                 <a:cs typeface="Microsoft YaHei" pitchFamily="34" charset="-120"/>
               </a:rPr>
-              <a:t>两个快照里，条件读到的每张表的事务性版本都相同 ⇒ 条件在两个快照上的结论相同。</a:t>
+              <a:t>两个快照里，条件读到的每张表的事务性版本都相同 ⇒ 条件在两个快照上的检查结果相同。</a:t>
             </a:r>
             <a:endParaRPr lang="en-US" sz="1500" dirty="0"/>
           </a:p>
@@ -7065,7 +7065,7 @@
                 <a:ea typeface="Microsoft YaHei" pitchFamily="34" charset="-122"/>
                 <a:cs typeface="Microsoft YaHei" pitchFamily="34" charset="-120"/>
               </a:rPr>
-              <a:t>并发写入下：执行前检查 3.8–4.6% 的使用在违规数据上作答，绑定快照一次也没有。</a:t>
+              <a:t>并发写入下：先检查后执行 3.8–4.6% 的使用在违规数据上作答，同快照验证一次也没有。</a:t>
             </a:r>
             <a:endParaRPr lang="en-US" sz="1600" dirty="0"/>
           </a:p>
@@ -7181,7 +7181,7 @@
                 <a:ea typeface="Microsoft YaHei" pitchFamily="34" charset="-122"/>
                 <a:cs typeface="Microsoft YaHei" pitchFamily="34" charset="-120"/>
               </a:rPr>
-              <a:t>处理失效：三道关才发布修复，否则撤下</a:t>
+              <a:t>处理失效：三道关才发布修复，否则让它失效</a:t>
             </a:r>
             <a:endParaRPr lang="en-US" sz="2900" dirty="0"/>
           </a:p>
@@ -7728,7 +7728,7 @@
                 <a:ea typeface="Microsoft YaHei" pitchFamily="34" charset="-122"/>
                 <a:cs typeface="Microsoft YaHei" pitchFamily="34" charset="-120"/>
               </a:rPr>
-              <a:t>都撤下口径</a:t>
+              <a:t>都让口径失效</a:t>
             </a:r>
             <a:endParaRPr lang="en-US" sz="1500" dirty="0"/>
           </a:p>
@@ -7931,7 +7931,7 @@
                 <a:ea typeface="Microsoft YaHei" pitchFamily="34" charset="-122"/>
                 <a:cs typeface="Microsoft YaHei" pitchFamily="34" charset="-120"/>
               </a:rPr>
-              <a:t>重新通过准入门槛，</a:t>
+              <a:t>重新通过准入检查，</a:t>
             </a:r>
             <a:endParaRPr lang="en-US" sz="1500" dirty="0"/>
           </a:p>
@@ -8020,7 +8020,7 @@
                 <a:ea typeface="Microsoft YaHei" pitchFamily="34" charset="-122"/>
                 <a:cs typeface="Microsoft YaHei" pitchFamily="34" charset="-120"/>
               </a:rPr>
-              <a:t>状态流水：修复成功</a:t>
+              <a:t>状态变更行：修复成功</a:t>
             </a:r>
             <a:endParaRPr lang="en-US" sz="1700" dirty="0"/>
           </a:p>
@@ -8131,7 +8131,7 @@
                 <a:ea typeface="Microsoft YaHei" pitchFamily="34" charset="-122"/>
                 <a:cs typeface="Microsoft YaHei" pitchFamily="34" charset="-120"/>
               </a:rPr>
-              <a:t>备份副本：撤下口径</a:t>
+              <a:t>备份副本：让口径失效</a:t>
             </a:r>
             <a:endParaRPr lang="en-US" sz="1700" dirty="0"/>
           </a:p>
@@ -8173,7 +8173,7 @@
                 <a:ea typeface="Microsoft YaHei" pitchFamily="34" charset="-122"/>
                 <a:cs typeface="Microsoft YaHei" pitchFamily="34" charset="-120"/>
               </a:rPr>
-              <a:t>“来源 = 主库”和“来源 = 备份”都能恢复粒度，结构上分不出真伪，所以撤下。</a:t>
+              <a:t>“来源 = 主库”和“来源 = 备份”都能恢复粒度，结构上分不出真伪，所以让它失效。</a:t>
             </a:r>
             <a:endParaRPr lang="en-US" sz="1500" dirty="0"/>
           </a:p>
@@ -8242,7 +8242,7 @@
                 <a:ea typeface="Microsoft YaHei" pitchFamily="34" charset="-122"/>
                 <a:cs typeface="Microsoft YaHei" pitchFamily="34" charset="-120"/>
               </a:rPr>
-              <a:t>宁可撤下口径，也不发布可能错的修复；修复进行中的请求等待结果，不重复算。</a:t>
+              <a:t>宁可让口径失效，也不发布可能错的修复；修复进行中的请求等待结果，不重复算。</a:t>
             </a:r>
             <a:endParaRPr lang="en-US" sz="1600" dirty="0"/>
           </a:p>
@@ -8358,7 +8358,7 @@
                 <a:ea typeface="Microsoft YaHei" pitchFamily="34" charset="-122"/>
                 <a:cs typeface="Microsoft YaHei" pitchFamily="34" charset="-120"/>
               </a:rPr>
-              <a:t>MAVRA：智能体与 PostgreSQL 之间的中间层</a:t>
+              <a:t>MAVRA：智能体与 PostgreSQL 之间的中间件</a:t>
             </a:r>
             <a:endParaRPr lang="en-US" sz="2700" dirty="0"/>
           </a:p>
@@ -9036,7 +9036,7 @@
                 <a:ea typeface="Microsoft YaHei" pitchFamily="34" charset="-122"/>
                 <a:cs typeface="Microsoft YaHei" pitchFamily="34" charset="-120"/>
               </a:rPr>
-              <a:t>七道门槛重放后发布</a:t>
+              <a:t>七项准入检查重放后发布</a:t>
             </a:r>
             <a:endParaRPr lang="en-US" sz="1450" dirty="0"/>
           </a:p>
@@ -9167,7 +9167,7 @@
                 <a:ea typeface="Microsoft YaHei" pitchFamily="34" charset="-122"/>
                 <a:cs typeface="Microsoft YaHei" pitchFamily="34" charset="-120"/>
               </a:rPr>
-              <a:t>复用结论 / 撤销 / 有界修复</a:t>
+              <a:t>复用检查结果 / 失效 / 有界修复</a:t>
             </a:r>
             <a:endParaRPr lang="en-US" sz="1450" dirty="0"/>
           </a:p>
@@ -9340,7 +9340,7 @@
                 <a:ea typeface="Microsoft YaHei" pitchFamily="34" charset="-122"/>
                 <a:cs typeface="Microsoft YaHei" pitchFamily="34" charset="-120"/>
               </a:rPr>
-              <a:t>口径、连接路径、粒度条目、结论和证据都带版本，保存在中间层的知识库里</a:t>
+              <a:t>口径、连接路径、粒度条目、检查结果和证据都带版本，保存在中间件的知识库里</a:t>
             </a:r>
             <a:endParaRPr lang="en-US" sz="1250" dirty="0"/>
           </a:p>
@@ -9787,7 +9787,7 @@
                 <a:ea typeface="Microsoft YaHei" pitchFamily="34" charset="-122"/>
                 <a:cs typeface="Microsoft YaHei" pitchFamily="34" charset="-120"/>
               </a:rPr>
-              <a:t>机制层：口径固定，只换维护方式</a:t>
+              <a:t>系统层：口径固定，只换维护方式</a:t>
             </a:r>
             <a:endParaRPr lang="en-US" sz="1800" dirty="0"/>
           </a:p>
@@ -9829,7 +9829,7 @@
                 <a:ea typeface="Microsoft YaHei" pitchFamily="34" charset="-122"/>
                 <a:cs typeface="Microsoft YaHei" pitchFamily="34" charset="-120"/>
               </a:rPr>
-              <a:t>配对回放：15 个学到的口径库（97 个口径）+ TPC-DS 模板库，各 11 种数据变化</a:t>
+              <a:t>定义库回放：15 个学到的口径库（97 个口径）+ TPC-DS 模板库，各 11 种数据变化</a:t>
             </a:r>
             <a:endParaRPr lang="en-US" sz="1450" dirty="0"/>
           </a:p>
@@ -9858,7 +9858,7 @@
                 <a:ea typeface="Microsoft YaHei" pitchFamily="34" charset="-122"/>
                 <a:cs typeface="Microsoft YaHei" pitchFamily="34" charset="-120"/>
               </a:rPr>
-              <a:t>并发写入：执行前检查 vs 绑定快照，确定性交错 + 随机并发</a:t>
+              <a:t>并发写入：先检查后执行 vs 同快照验证，确定性交错 + 随机并发</a:t>
             </a:r>
             <a:endParaRPr lang="en-US" sz="1450" dirty="0"/>
           </a:p>
@@ -9887,7 +9887,7 @@
                 <a:ea typeface="Microsoft YaHei" pitchFamily="34" charset="-122"/>
                 <a:cs typeface="Microsoft YaHei" pitchFamily="34" charset="-120"/>
               </a:rPr>
-              <a:t>维护代价：定义级 / 通用缓存 / MAVRA，100 万–1600 万行，8–32 个脚本智能体</a:t>
+              <a:t>维护代价：定义级 / 检查结果缓存 / MAVRA，100 万–1600 万行，8–32 个脚本智能体</a:t>
             </a:r>
             <a:endParaRPr lang="en-US" sz="1450" dirty="0"/>
           </a:p>
@@ -10094,7 +10094,7 @@
                 <a:ea typeface="Microsoft YaHei" pitchFamily="34" charset="-122"/>
                 <a:cs typeface="Microsoft YaHei" pitchFamily="34" charset="-120"/>
               </a:rPr>
-              <a:t>11 种数据变化：状态流水、版本化更正、维表拉链、重复装载、日期键改写（条件能发现）；备份副本（修复有歧义）；4 种正常追加；单位换算（对照）</a:t>
+              <a:t>11 种数据变化：状态变更行、多版本更正、缓慢变化维、重复加载、日期键格式变化（条件能发现）；备份副本（修复有歧义）；4 种正常追加；单位换算（对照）</a:t>
             </a:r>
             <a:endParaRPr lang="en-US" sz="1450" dirty="0"/>
           </a:p>
@@ -10192,7 +10192,7 @@
                 <a:ea typeface="Microsoft YaHei" pitchFamily="34" charset="-122"/>
                 <a:cs typeface="Microsoft YaHei" pitchFamily="34" charset="-120"/>
               </a:rPr>
-              <a:t>机制层回答“维护对不对、贵不贵”，端到端回答“对使用者有没有用”。</a:t>
+              <a:t>系统层回答“维护对不对、贵不贵”，端到端回答“对使用者有没有用”。</a:t>
             </a:r>
             <a:endParaRPr lang="en-US" sz="1600" dirty="0"/>
           </a:p>
@@ -10300,7 +10300,7 @@
               <a:buNone/>
             </a:pPr>
             <a:r>
-              <a:rPr lang="en-US" sz="2700" b="1" dirty="0">
+              <a:rPr lang="en-US" sz="2500" b="1" dirty="0">
                 <a:solidFill>
                   <a:srgbClr val="1B2A41"/>
                 </a:solidFill>
@@ -10308,9 +10308,9 @@
                 <a:ea typeface="Microsoft YaHei" pitchFamily="34" charset="-122"/>
                 <a:cs typeface="Microsoft YaHei" pitchFamily="34" charset="-120"/>
               </a:rPr>
-              <a:t>数据变化后：维护后的口径零错误答案，只看结构 645 个</a:t>
-            </a:r>
-            <a:endParaRPr lang="en-US" sz="2700" dirty="0"/>
+              <a:t>数据变化后：维护后的口径零错误答案，按模式变更失效 629 个</a:t>
+            </a:r>
+            <a:endParaRPr lang="en-US" sz="2500" dirty="0"/>
           </a:p>
         </p:txBody>
       </p:sp>
@@ -10392,7 +10392,7 @@
                 <a:ea typeface="Microsoft YaHei" pitchFamily="34" charset="-122"/>
                 <a:cs typeface="Microsoft YaHei" pitchFamily="34" charset="-120"/>
               </a:rPr>
-              <a:t>论文 §7.2；gen/review.tex；表 4</a:t>
+              <a:t>论文 §7.2；gen/review.tex；图 4</a:t>
             </a:r>
             <a:endParaRPr lang="en-US" sz="850" dirty="0"/>
           </a:p>
@@ -10760,7 +10760,7 @@
                           <a:ea typeface="Microsoft YaHei" pitchFamily="34" charset="-122"/>
                           <a:cs typeface="Microsoft YaHei" pitchFamily="34" charset="-120"/>
                         </a:rPr>
-                        <a:t>只看结构</a:t>
+                        <a:t>按模式变更失效</a:t>
                       </a:r>
                       <a:endParaRPr lang="en-US" sz="1500" dirty="0">
                         <a:latin typeface="Microsoft YaHei" charset="0"/>
@@ -10828,7 +10828,7 @@
                           <a:ea typeface="Microsoft YaHei" pitchFamily="34" charset="-122"/>
                           <a:cs typeface="Microsoft YaHei" pitchFamily="34" charset="-120"/>
                         </a:rPr>
-                        <a:t>784</a:t>
+                        <a:t>742</a:t>
                       </a:r>
                       <a:endParaRPr lang="en-US" sz="1500" dirty="0">
                         <a:latin typeface="Microsoft YaHei" charset="0"/>
@@ -10896,7 +10896,7 @@
                           <a:ea typeface="Microsoft YaHei" pitchFamily="34" charset="-122"/>
                           <a:cs typeface="Microsoft YaHei" pitchFamily="34" charset="-120"/>
                         </a:rPr>
-                        <a:t>746</a:t>
+                        <a:t>728</a:t>
                       </a:r>
                       <a:endParaRPr lang="en-US" sz="1500" dirty="0">
                         <a:latin typeface="Microsoft YaHei" charset="0"/>
@@ -10964,7 +10964,7 @@
                           <a:ea typeface="Microsoft YaHei" pitchFamily="34" charset="-122"/>
                           <a:cs typeface="Microsoft YaHei" pitchFamily="34" charset="-120"/>
                         </a:rPr>
-                        <a:t>645</a:t>
+                        <a:t>629</a:t>
                       </a:r>
                       <a:endParaRPr lang="en-US" sz="1500" dirty="0">
                         <a:latin typeface="Microsoft YaHei" charset="0"/>
@@ -11102,7 +11102,7 @@
                           <a:ea typeface="Microsoft YaHei" pitchFamily="34" charset="-122"/>
                           <a:cs typeface="Microsoft YaHei" pitchFamily="34" charset="-120"/>
                         </a:rPr>
-                        <a:t>631</a:t>
+                        <a:t>603</a:t>
                       </a:r>
                       <a:endParaRPr lang="en-US" sz="1500" dirty="0">
                         <a:latin typeface="Microsoft YaHei" charset="0"/>
@@ -11170,7 +11170,7 @@
                           <a:ea typeface="Microsoft YaHei" pitchFamily="34" charset="-122"/>
                           <a:cs typeface="Microsoft YaHei" pitchFamily="34" charset="-120"/>
                         </a:rPr>
-                        <a:t>101</a:t>
+                        <a:t>99</a:t>
                       </a:r>
                       <a:endParaRPr lang="en-US" sz="1500" dirty="0">
                         <a:latin typeface="Microsoft YaHei" charset="0"/>
@@ -11376,7 +11376,7 @@
                           <a:ea typeface="Microsoft YaHei" pitchFamily="34" charset="-122"/>
                           <a:cs typeface="Microsoft YaHei" pitchFamily="34" charset="-120"/>
                         </a:rPr>
-                        <a:t>973</a:t>
+                        <a:t>780</a:t>
                       </a:r>
                       <a:endParaRPr lang="en-US" sz="1500" dirty="0">
                         <a:latin typeface="Microsoft YaHei" charset="0"/>
@@ -11444,7 +11444,7 @@
                           <a:ea typeface="Microsoft YaHei" pitchFamily="34" charset="-122"/>
                           <a:cs typeface="Microsoft YaHei" pitchFamily="34" charset="-120"/>
                         </a:rPr>
-                        <a:t>101</a:t>
+                        <a:t>99</a:t>
                       </a:r>
                       <a:endParaRPr lang="en-US" sz="1500" dirty="0">
                         <a:latin typeface="Microsoft YaHei" charset="0"/>
@@ -11650,7 +11650,7 @@
                           <a:ea typeface="Microsoft YaHei" pitchFamily="34" charset="-122"/>
                           <a:cs typeface="Microsoft YaHei" pitchFamily="34" charset="-120"/>
                         </a:rPr>
-                        <a:t>973</a:t>
+                        <a:t>780</a:t>
                       </a:r>
                       <a:endParaRPr lang="en-US" sz="1500" dirty="0">
                         <a:latin typeface="Microsoft YaHei" charset="0"/>
@@ -11718,7 +11718,7 @@
                           <a:ea typeface="Microsoft YaHei" pitchFamily="34" charset="-122"/>
                           <a:cs typeface="Microsoft YaHei" pitchFamily="34" charset="-120"/>
                         </a:rPr>
-                        <a:t>101</a:t>
+                        <a:t>99</a:t>
                       </a:r>
                       <a:endParaRPr lang="en-US" sz="1500" dirty="0">
                         <a:latin typeface="Microsoft YaHei" charset="0"/>
@@ -11878,7 +11878,7 @@
                 <a:ea typeface="Microsoft YaHei" pitchFamily="34" charset="-122"/>
                 <a:cs typeface="Microsoft YaHei" pitchFamily="34" charset="-120"/>
               </a:rPr>
-              <a:t>每种方法 1,530 道配对题；101 个错误全部来自单位换算这个对照。</a:t>
+              <a:t>每种方法 1,470 道配对题；99 个错误全部来自单位换算这个对照。</a:t>
             </a:r>
             <a:endParaRPr lang="en-US" sz="1350" dirty="0"/>
           </a:p>
@@ -11920,7 +11920,7 @@
                 <a:ea typeface="Microsoft YaHei" pitchFamily="34" charset="-122"/>
                 <a:cs typeface="Microsoft YaHei" pitchFamily="34" charset="-120"/>
               </a:rPr>
-              <a:t>0 vs 645</a:t>
+              <a:t>0 vs 629</a:t>
             </a:r>
             <a:endParaRPr lang="en-US" sz="3400" dirty="0"/>
           </a:p>
@@ -11982,7 +11982,7 @@
                 <a:ea typeface="Microsoft YaHei" pitchFamily="34" charset="-122"/>
                 <a:cs typeface="Microsoft YaHei" pitchFamily="34" charset="-120"/>
               </a:rPr>
-              <a:t>MAVRA vs 只看结构（学到的库）</a:t>
+              <a:t>MAVRA vs 按模式变更失效（学到的库）</a:t>
             </a:r>
             <a:endParaRPr lang="en-US" sz="1500" dirty="0"/>
           </a:p>
@@ -12155,7 +12155,7 @@
                 <a:ea typeface="Microsoft YaHei" pitchFamily="34" charset="-122"/>
                 <a:cs typeface="Microsoft YaHei" pitchFamily="34" charset="-120"/>
               </a:rPr>
-              <a:t>表级测试也能隔离破坏，但不会修：MAVRA 多答对 342 题，来自修复或口径自带的过滤。</a:t>
+              <a:t>表级测试也能让被破坏的口径失效，但不会修：MAVRA 多答对 177 题，来自修复或口径自带的过滤。</a:t>
             </a:r>
             <a:endParaRPr lang="en-US" sz="1600" dirty="0"/>
           </a:p>
@@ -12263,7 +12263,7 @@
               <a:buNone/>
             </a:pPr>
             <a:r>
-              <a:rPr lang="en-US" sz="2700" b="1" dirty="0">
+              <a:rPr lang="en-US" sz="2500" b="1" dirty="0">
                 <a:solidFill>
                   <a:srgbClr val="1B2A41"/>
                 </a:solidFill>
@@ -12271,9 +12271,9 @@
                 <a:ea typeface="Microsoft YaHei" pitchFamily="34" charset="-122"/>
                 <a:cs typeface="Microsoft YaHei" pitchFamily="34" charset="-120"/>
               </a:rPr>
-              <a:t>并发写入：执行前检查 4.6% 违规作答，绑定快照一次没有</a:t>
-            </a:r>
-            <a:endParaRPr lang="en-US" sz="2700" dirty="0"/>
+              <a:t>并发写入：先检查后执行 4.6% 违规作答，同快照验证一次没有</a:t>
+            </a:r>
+            <a:endParaRPr lang="en-US" sz="2500" dirty="0"/>
           </a:p>
         </p:txBody>
       </p:sp>
@@ -12481,7 +12481,7 @@
                 <a:ea typeface="Microsoft YaHei" pitchFamily="34" charset="-122"/>
                 <a:cs typeface="Microsoft YaHei" pitchFamily="34" charset="-120"/>
               </a:rPr>
-              <a:t>执行前检查：未通知的写入下</a:t>
+              <a:t>先检查后执行：未通知的写入下</a:t>
             </a:r>
             <a:endParaRPr lang="en-US" sz="1500" dirty="0"/>
           </a:p>
@@ -12585,7 +12585,7 @@
                 <a:ea typeface="Microsoft YaHei" pitchFamily="34" charset="-122"/>
                 <a:cs typeface="Microsoft YaHei" pitchFamily="34" charset="-120"/>
               </a:rPr>
-              <a:t>绑定快照：随机并发合计</a:t>
+              <a:t>同快照验证：随机并发合计</a:t>
             </a:r>
             <a:endParaRPr lang="en-US" sz="1500" dirty="0"/>
           </a:p>
@@ -13626,7 +13626,7 @@
                 <a:ea typeface="Microsoft YaHei" pitchFamily="34" charset="-122"/>
                 <a:cs typeface="Microsoft YaHei" pitchFamily="34" charset="-120"/>
               </a:rPr>
-              <a:t>19 个口径：MAVRA 为定义级的 14.0%，通用缓存 16.7%。</a:t>
+              <a:t>19 个口径：MAVRA 为定义级的 14.0%，检查结果缓存 16.7%。</a:t>
             </a:r>
             <a:endParaRPr lang="en-US" sz="1600" dirty="0"/>
           </a:p>
@@ -13743,7 +13743,7 @@
                 <a:ea typeface="Microsoft YaHei" pitchFamily="34" charset="-122"/>
                 <a:cs typeface="Microsoft YaHei" pitchFamily="34" charset="-120"/>
               </a:rPr>
-              <a:t>节省来自结论共享，通用版本缓存也能拿到；论文的贡献在条件、使用保证和修复规则。</a:t>
+              <a:t>节省来自检查结果共享，检查结果缓存也能拿到；论文的贡献在条件、使用保证和修复规则。</a:t>
             </a:r>
             <a:endParaRPr lang="en-US" sz="1600" dirty="0"/>
           </a:p>
@@ -13859,7 +13859,7 @@
                 <a:ea typeface="Microsoft YaHei" pitchFamily="34" charset="-122"/>
                 <a:cs typeface="Microsoft YaHei" pitchFamily="34" charset="-120"/>
               </a:rPr>
-              <a:t>端到端：共享把正确率从 32% 提到 75%，维护再拉开 16 个点</a:t>
+              <a:t>端到端：共享把正确率从 32% 提到 75%，维护再拉开 17 个点</a:t>
             </a:r>
             <a:endParaRPr lang="en-US" sz="2500" dirty="0"/>
           </a:p>
@@ -14113,7 +14113,7 @@
                 <a:ea typeface="Microsoft YaHei" pitchFamily="34" charset="-122"/>
                 <a:cs typeface="Microsoft YaHei" pitchFamily="34" charset="-120"/>
               </a:rPr>
-              <a:t>破坏性变化：MAVRA 73% vs 轨迹检索 57%；预登记的差 +16（95% 区间 14–18）。</a:t>
+              <a:t>破坏性变化：MAVRA 74% vs 轨迹检索 57%；预登记的差 +17（95% 区间 15–18）。</a:t>
             </a:r>
             <a:endParaRPr lang="en-US" sz="1500" dirty="0"/>
           </a:p>
@@ -14179,7 +14179,7 @@
                 <a:ea typeface="Microsoft YaHei" pitchFamily="34" charset="-122"/>
                 <a:cs typeface="Microsoft YaHei" pitchFamily="34" charset="-120"/>
               </a:rPr>
-              <a:t>反例：备份副本下 MAVRA 撤下口径，这一组 61% 低于检索的 72%。</a:t>
+              <a:t>反例：备份副本下 MAVRA 让口径失效，这一组 61% 低于检索的 72%。</a:t>
             </a:r>
             <a:endParaRPr lang="en-US" sz="1400" dirty="0"/>
           </a:p>
@@ -15569,7 +15569,7 @@
                           <a:ea typeface="Microsoft YaHei" pitchFamily="34" charset="-122"/>
                           <a:cs typeface="Microsoft YaHei" pitchFamily="34" charset="-120"/>
                         </a:rPr>
-                        <a:t>通用版本缓存</a:t>
+                        <a:t>检查结果缓存</a:t>
                       </a:r>
                       <a:endParaRPr lang="en-US" sz="1500" dirty="0">
                         <a:latin typeface="Microsoft YaHei" charset="0"/>
@@ -16587,7 +16587,7 @@
                 <a:ea typeface="Microsoft YaHei" pitchFamily="34" charset="-122"/>
                 <a:cs typeface="Microsoft YaHei" pitchFamily="34" charset="-120"/>
               </a:rPr>
-              <a:t>节省来自共享：定义级 32.97 秒、通用缓存 31.97 秒，维护方式之间没有延迟优势。</a:t>
+              <a:t>节省来自共享：定义级 32.97 秒、检查结果缓存 31.97 秒，维护方式之间没有延迟优势。</a:t>
             </a:r>
             <a:endParaRPr lang="en-US" sz="1300" dirty="0"/>
           </a:p>
@@ -17519,7 +17519,7 @@
                 <a:ea typeface="Microsoft YaHei" pitchFamily="34" charset="-122"/>
                 <a:cs typeface="Microsoft YaHei" pitchFamily="34" charset="-120"/>
               </a:rPr>
-              <a:t>把成立条件记录为可执行检查，随数据版本维护，查询只在检查通过的数据上执行；坏了只做唯一且过回归的修复，否则撤下。</a:t>
+              <a:t>把成立条件记录为可执行检查，随数据版本维护，查询只在检查通过的数据上执行；坏了只做唯一且过回归的修复，否则让它失效。</a:t>
             </a:r>
             <a:endParaRPr lang="en-US" sz="1500" dirty="0"/>
           </a:p>
@@ -17697,7 +17697,7 @@
                 <a:ea typeface="Microsoft YaHei" pitchFamily="34" charset="-122"/>
                 <a:cs typeface="Microsoft YaHei" pitchFamily="34" charset="-120"/>
               </a:rPr>
-              <a:t>破坏性数据变化下，智能体正确率 73%，对照的轨迹检索 57%。</a:t>
+              <a:t>破坏性数据变化下，智能体正确率 74%，对照的轨迹检索 57%。</a:t>
             </a:r>
             <a:endParaRPr lang="en-US" sz="1500" dirty="0"/>
           </a:p>
@@ -18244,7 +18244,7 @@
                 <a:ea typeface="Microsoft YaHei" pitchFamily="34" charset="-122"/>
                 <a:cs typeface="Microsoft YaHei" pitchFamily="34" charset="-120"/>
               </a:rPr>
-              <a:t>声明口径 + 绑定快照：条件在所读数据上成立。</a:t>
+              <a:t>声明口径 + 同快照验证：条件在所读数据上成立。</a:t>
             </a:r>
             <a:endParaRPr lang="en-US" sz="1450" dirty="0"/>
           </a:p>
@@ -19167,7 +19167,7 @@
                 <a:ea typeface="Microsoft YaHei" pitchFamily="34" charset="-122"/>
                 <a:cs typeface="Microsoft YaHei" pitchFamily="34" charset="-120"/>
               </a:rPr>
-              <a:t>③ 有界修复算法：唯一、不丢键、过回归，否则撤下（算法 1）</a:t>
+              <a:t>③ 有界修复算法：唯一、不丢键、过回归，否则让它失效（算法 1）</a:t>
             </a:r>
             <a:endParaRPr lang="en-US" sz="1450" dirty="0"/>
           </a:p>
@@ -19196,7 +19196,7 @@
                 <a:ea typeface="Microsoft YaHei" pitchFamily="34" charset="-122"/>
                 <a:cs typeface="Microsoft YaHei" pitchFamily="34" charset="-120"/>
               </a:rPr>
-              <a:t>④ 实现与两层评估：配对回放、TPC-DS、并发、代价、端到端</a:t>
+              <a:t>④ 实现与两层评估：定义库回放、TPC-DS、并发、代价、端到端</a:t>
             </a:r>
             <a:endParaRPr lang="en-US" sz="1450" dirty="0"/>
           </a:p>
@@ -19730,7 +19730,7 @@
                 <a:ea typeface="Microsoft YaHei" pitchFamily="34" charset="-122"/>
                 <a:cs typeface="Microsoft YaHei" pitchFamily="34" charset="-120"/>
               </a:rPr>
-              <a:t>①  记录：从口径推出粒度、连接、时间角色、覆盖四类条件</a:t>
+              <a:t>①  记录：从口径推出粒度、连接、日期角色、日期键完整性四类条件</a:t>
             </a:r>
             <a:endParaRPr lang="en-US" sz="2000" dirty="0"/>
           </a:p>
@@ -19753,7 +19753,7 @@
                 <a:ea typeface="Microsoft YaHei" pitchFamily="34" charset="-122"/>
                 <a:cs typeface="Microsoft YaHei" pitchFamily="34" charset="-120"/>
               </a:rPr>
-              <a:t>②  维护：结论按数据版本保存，更新后只重查受影响的条件</a:t>
+              <a:t>②  维护：检查结果按数据版本保存，更新后只重查受影响的条件</a:t>
             </a:r>
             <a:endParaRPr lang="en-US" sz="2000" dirty="0"/>
           </a:p>
@@ -19799,7 +19799,7 @@
                 <a:ea typeface="Microsoft YaHei" pitchFamily="34" charset="-122"/>
                 <a:cs typeface="Microsoft YaHei" pitchFamily="34" charset="-120"/>
               </a:rPr>
-              <a:t>④  处理失效：唯一且过回归才修复，否则撤下</a:t>
+              <a:t>④  处理失效：唯一且过回归才修复，否则让它失效</a:t>
             </a:r>
             <a:endParaRPr lang="en-US" sz="2000" dirty="0"/>
           </a:p>
@@ -20354,7 +20354,7 @@
                 <a:ea typeface="Microsoft YaHei" pitchFamily="34" charset="-122"/>
                 <a:cs typeface="Microsoft YaHei" pitchFamily="34" charset="-120"/>
               </a:rPr>
-              <a:t>B1、B2 与 C(mʳ) 在快照 Dₛ 上成立 ⇒ 对每个期间 p，规范 SQL 返回角色日期落在 p 内的事件度量的聚合，每个事件恰好贡献一次；遗漏仅为日期键匹配不到日期维度的事件，其比例受覆盖条件约束。</a:t>
+              <a:t>B1、B2 与 C(mʳ) 在快照 Dₛ 上成立 ⇒ 对每个期间 p，规范 SQL 返回角色日期落在 p 内的事件度量的聚合，每个事件恰好贡献一次；遗漏仅为日期键匹配不到日期维度的事件，其比例受完整性条件约束。</a:t>
             </a:r>
             <a:endParaRPr lang="en-US" sz="1350" dirty="0"/>
           </a:p>
@@ -20423,7 +20423,7 @@
                 <a:ea typeface="Microsoft YaHei" pitchFamily="34" charset="-122"/>
                 <a:cs typeface="Microsoft YaHei" pitchFamily="34" charset="-120"/>
               </a:rPr>
-              <a:t>引理 1（结论复用）</a:t>
+              <a:t>引理 1（检查结果复用）</a:t>
             </a:r>
             <a:endParaRPr lang="en-US" sz="1600" dirty="0"/>
           </a:p>
@@ -20576,7 +20576,7 @@
                 <a:ea typeface="Microsoft YaHei" pitchFamily="34" charset="-122"/>
                 <a:cs typeface="Microsoft YaHei" pitchFamily="34" charset="-120"/>
               </a:rPr>
-              <a:t>粒度条件失效 → 在低基数列上枚举等值过滤 → 保留恢复一键一行且不丢业务键的候选 → 候选恰好一个 → 通过准入门槛 G3–G5 与回归 G8 → 发布新修订；任一步失败则撤下口径。</a:t>
+              <a:t>粒度条件失效 → 在低基数列上枚举等值过滤 → 保留恢复一键一行且不丢业务键的候选 → 候选恰好一个 → 通过准入检查 G3–G5 与回归 G8 → 发布新修订；任一步失败则让口径失效。</a:t>
             </a:r>
             <a:endParaRPr lang="en-US" sz="1350" dirty="0"/>
           </a:p>
@@ -20753,7 +20753,7 @@
               <a:buNone/>
             </a:pPr>
             <a:r>
-              <a:rPr lang="en-US" sz="2900" b="1" dirty="0">
+              <a:rPr lang="en-US" sz="2700" b="1" dirty="0">
                 <a:solidFill>
                   <a:srgbClr val="1B2A41"/>
                 </a:solidFill>
@@ -20761,9 +20761,9 @@
                 <a:ea typeface="Microsoft YaHei" pitchFamily="34" charset="-122"/>
                 <a:cs typeface="Microsoft YaHei" pitchFamily="34" charset="-120"/>
               </a:rPr>
-              <a:t>修复参照决定自动化范围，唯一性规则挡住歧义</a:t>
-            </a:r>
-            <a:endParaRPr lang="en-US" sz="2900" dirty="0"/>
+              <a:t>回归对照决定修复能自动完成多少，唯一性规则挡住歧义</a:t>
+            </a:r>
+            <a:endParaRPr lang="en-US" sz="2700" dirty="0"/>
           </a:p>
         </p:txBody>
       </p:sp>
@@ -20938,7 +20938,7 @@
                           <a:ea typeface="Microsoft YaHei" pitchFamily="34" charset="-122"/>
                           <a:cs typeface="Microsoft YaHei" pitchFamily="34" charset="-120"/>
                         </a:rPr>
-                        <a:t>同一批配对题</a:t>
+                        <a:t>同一批题</a:t>
                       </a:r>
                       <a:endParaRPr lang="en-US" sz="1550" dirty="0">
                         <a:latin typeface="Microsoft YaHei" charset="0"/>
@@ -21006,7 +21006,7 @@
                           <a:ea typeface="Microsoft YaHei" pitchFamily="34" charset="-122"/>
                           <a:cs typeface="Microsoft YaHei" pitchFamily="34" charset="-120"/>
                         </a:rPr>
-                        <a:t>判题学习查询作参照</a:t>
+                        <a:t>MAVRA（智能体自己的 SQL）</a:t>
                       </a:r>
                       <a:endParaRPr lang="en-US" sz="1550" dirty="0">
                         <a:latin typeface="Microsoft YaHei" charset="0"/>
@@ -21074,7 +21074,7 @@
                           <a:ea typeface="Microsoft YaHei" pitchFamily="34" charset="-122"/>
                           <a:cs typeface="Microsoft YaHei" pitchFamily="34" charset="-120"/>
                         </a:rPr>
-                        <a:t>智能体学习 SQL 作参照</a:t>
+                        <a:t>MAVRA（标准答案 SQL）</a:t>
                       </a:r>
                       <a:endParaRPr lang="en-US" sz="1550" dirty="0">
                         <a:latin typeface="Microsoft YaHei" charset="0"/>
@@ -21212,7 +21212,7 @@
                           <a:ea typeface="Microsoft YaHei" pitchFamily="34" charset="-122"/>
                           <a:cs typeface="Microsoft YaHei" pitchFamily="34" charset="-120"/>
                         </a:rPr>
-                        <a:t>933</a:t>
+                        <a:t>780</a:t>
                       </a:r>
                       <a:endParaRPr lang="en-US" sz="1550" dirty="0">
                         <a:latin typeface="Microsoft YaHei" charset="0"/>
@@ -21280,7 +21280,7 @@
                           <a:ea typeface="Microsoft YaHei" pitchFamily="34" charset="-122"/>
                           <a:cs typeface="Microsoft YaHei" pitchFamily="34" charset="-120"/>
                         </a:rPr>
-                        <a:t>780</a:t>
+                        <a:t>933</a:t>
                       </a:r>
                       <a:endParaRPr lang="en-US" sz="1550" dirty="0">
                         <a:latin typeface="Microsoft YaHei" charset="0"/>
@@ -21350,7 +21350,7 @@
                           <a:ea typeface="Microsoft YaHei" pitchFamily="34" charset="-122"/>
                           <a:cs typeface="Microsoft YaHei" pitchFamily="34" charset="-120"/>
                         </a:rPr>
-                        <a:t>新增错误</a:t>
+                        <a:t>自动发布的修复（端到端，每次运行）</a:t>
                       </a:r>
                       <a:endParaRPr lang="en-US" sz="1550" dirty="0">
                         <a:latin typeface="Microsoft YaHei" charset="0"/>
@@ -21406,7 +21406,7 @@
                     <a:bodyPr/>
                     <a:lstStyle/>
                     <a:p>
-                      <a:pPr algn="l" indent="0" marL="0">
+                      <a:pPr algn="r" indent="0" marL="0">
                         <a:buNone/>
                       </a:pPr>
                       <a:r>
@@ -21418,7 +21418,7 @@
                           <a:ea typeface="Microsoft YaHei" pitchFamily="34" charset="-122"/>
                           <a:cs typeface="Microsoft YaHei" pitchFamily="34" charset="-120"/>
                         </a:rPr>
-                        <a:t>—</a:t>
+                        <a:t>4.7</a:t>
                       </a:r>
                       <a:endParaRPr lang="en-US" sz="1550" dirty="0">
                         <a:latin typeface="Microsoft YaHei" charset="0"/>
@@ -21474,7 +21474,7 @@
                     <a:bodyPr/>
                     <a:lstStyle/>
                     <a:p>
-                      <a:pPr algn="l" indent="0" marL="0">
+                      <a:pPr algn="r" indent="0" marL="0">
                         <a:buNone/>
                       </a:pPr>
                       <a:r>
@@ -21486,7 +21486,7 @@
                           <a:ea typeface="Microsoft YaHei" pitchFamily="34" charset="-122"/>
                           <a:cs typeface="Microsoft YaHei" pitchFamily="34" charset="-120"/>
                         </a:rPr>
-                        <a:t>0（差别全部转为不可用）</a:t>
+                        <a:t>8.0</a:t>
                       </a:r>
                       <a:endParaRPr lang="en-US" sz="1550" dirty="0">
                         <a:latin typeface="Microsoft YaHei" charset="0"/>
@@ -21624,7 +21624,7 @@
                           <a:ea typeface="Microsoft YaHei" pitchFamily="34" charset="-122"/>
                           <a:cs typeface="Microsoft YaHei" pitchFamily="34" charset="-120"/>
                         </a:rPr>
-                        <a:t>73%</a:t>
+                        <a:t>74%</a:t>
                       </a:r>
                       <a:endParaRPr lang="en-US" sz="1550" dirty="0">
                         <a:latin typeface="Microsoft YaHei" charset="0"/>
@@ -21692,7 +21692,7 @@
                           <a:ea typeface="Microsoft YaHei" pitchFamily="34" charset="-122"/>
                           <a:cs typeface="Microsoft YaHei" pitchFamily="34" charset="-120"/>
                         </a:rPr>
-                        <a:t>74%</a:t>
+                        <a:t>73%</a:t>
                       </a:r>
                       <a:endParaRPr lang="en-US" sz="1550" dirty="0">
                         <a:latin typeface="Microsoft YaHei" charset="0"/>
@@ -21853,7 +21853,7 @@
                 <a:ea typeface="Microsoft YaHei" pitchFamily="34" charset="-122"/>
                 <a:cs typeface="Microsoft YaHei" pitchFamily="34" charset="-120"/>
               </a:rPr>
-              <a:t>不要求候选唯一时可发布错误修复；要求唯一时两种参照均撤下口径。</a:t>
+              <a:t>不要求候选唯一时可发布错误修复；要求唯一时两种参照均让口径失效。</a:t>
             </a:r>
             <a:endParaRPr lang="en-US" sz="1500" dirty="0"/>
           </a:p>
@@ -22033,7 +22033,7 @@
                 <a:ea typeface="Microsoft YaHei" pitchFamily="34" charset="-122"/>
                 <a:cs typeface="Microsoft YaHei" pitchFamily="34" charset="-120"/>
               </a:rPr>
-              <a:t>回归参照只有在变化触及学习期间、且参照反映区分列时，才提供额外分辨力。</a:t>
+              <a:t>对照只决定修复能自动完成多少，不决定会不会答错；变化不触及学习期时，智能体自己的 SQL 就够了。</a:t>
             </a:r>
             <a:endParaRPr lang="en-US" sz="1600" dirty="0"/>
           </a:p>
@@ -23012,7 +23012,7 @@
                           <a:ea typeface="Microsoft YaHei" pitchFamily="34" charset="-122"/>
                           <a:cs typeface="Microsoft YaHei" pitchFamily="34" charset="-120"/>
                         </a:rPr>
-                        <a:t>只看结构</a:t>
+                        <a:t>按模式变更失效</a:t>
                       </a:r>
                       <a:endParaRPr lang="en-US" sz="1400" dirty="0">
                         <a:latin typeface="Microsoft YaHei" charset="0"/>
@@ -23490,7 +23490,7 @@
                           <a:ea typeface="Microsoft YaHei" pitchFamily="34" charset="-122"/>
                           <a:cs typeface="Microsoft YaHei" pitchFamily="34" charset="-120"/>
                         </a:rPr>
-                        <a:t>隔离相关表上的口径</a:t>
+                        <a:t>让相关表上的口径失效</a:t>
                       </a:r>
                       <a:endParaRPr lang="en-US" sz="1400" dirty="0">
                         <a:latin typeface="Microsoft YaHei" charset="0"/>
@@ -23558,7 +23558,7 @@
                           <a:ea typeface="Microsoft YaHei" pitchFamily="34" charset="-122"/>
                           <a:cs typeface="Microsoft YaHei" pitchFamily="34" charset="-120"/>
                         </a:rPr>
-                        <a:t>执行前的测试</a:t>
+                        <a:t>先测试后执行</a:t>
                       </a:r>
                       <a:endParaRPr lang="en-US" sz="1400" dirty="0">
                         <a:latin typeface="Microsoft YaHei" charset="0"/>
@@ -23696,7 +23696,7 @@
                           <a:ea typeface="Microsoft YaHei" pitchFamily="34" charset="-122"/>
                           <a:cs typeface="Microsoft YaHei" pitchFamily="34" charset="-120"/>
                         </a:rPr>
-                        <a:t>写入即撤销</a:t>
+                        <a:t>写入即失效</a:t>
                       </a:r>
                       <a:endParaRPr lang="en-US" sz="1400" dirty="0">
                         <a:latin typeface="Microsoft YaHei" charset="0"/>
@@ -23764,7 +23764,7 @@
                           <a:ea typeface="Microsoft YaHei" pitchFamily="34" charset="-122"/>
                           <a:cs typeface="Microsoft YaHei" pitchFamily="34" charset="-120"/>
                         </a:rPr>
-                        <a:t>撤下并重学</a:t>
+                        <a:t>失效并重学</a:t>
                       </a:r>
                       <a:endParaRPr lang="en-US" sz="1400" dirty="0">
                         <a:latin typeface="Microsoft YaHei" charset="0"/>
@@ -23832,7 +23832,7 @@
                           <a:ea typeface="Microsoft YaHei" pitchFamily="34" charset="-122"/>
                           <a:cs typeface="Microsoft YaHei" pitchFamily="34" charset="-120"/>
                         </a:rPr>
-                        <a:t>撤下并重学</a:t>
+                        <a:t>失效并重学</a:t>
                       </a:r>
                       <a:endParaRPr lang="en-US" sz="1400" dirty="0">
                         <a:latin typeface="Microsoft YaHei" charset="0"/>
@@ -24242,7 +24242,7 @@
                           <a:ea typeface="Microsoft YaHei" pitchFamily="34" charset="-122"/>
                           <a:cs typeface="Microsoft YaHei" pitchFamily="34" charset="-120"/>
                         </a:rPr>
-                        <a:t>执行前检查</a:t>
+                        <a:t>先检查后执行</a:t>
                       </a:r>
                       <a:endParaRPr lang="en-US" sz="1400" dirty="0">
                         <a:latin typeface="Microsoft YaHei" charset="0"/>
@@ -24516,7 +24516,7 @@
                           <a:ea typeface="Microsoft YaHei" pitchFamily="34" charset="-122"/>
                           <a:cs typeface="Microsoft YaHei" pitchFamily="34" charset="-120"/>
                         </a:rPr>
-                        <a:t>有界修复或撤下</a:t>
+                        <a:t>有界修复或让它失效</a:t>
                       </a:r>
                       <a:endParaRPr lang="en-US" sz="1400" dirty="0">
                         <a:latin typeface="Microsoft YaHei" charset="0"/>
@@ -25182,7 +25182,7 @@
                 <a:ea typeface="Microsoft YaHei" pitchFamily="34" charset="-122"/>
                 <a:cs typeface="Microsoft YaHei" pitchFamily="34" charset="-120"/>
               </a:rPr>
-              <a:t>MAVRA 比通用缓存少 25.3% 的数据库查询时间。</a:t>
+              <a:t>MAVRA 比检查结果缓存少 25.3% 的数据库查询时间。</a:t>
             </a:r>
             <a:endParaRPr lang="en-US" sz="1500" dirty="0"/>
           </a:p>
@@ -30231,7 +30231,7 @@
                 <a:ea typeface="Microsoft YaHei" pitchFamily="34" charset="-122"/>
                 <a:cs typeface="Microsoft YaHei" pitchFamily="34" charset="-120"/>
               </a:rPr>
-              <a:t>5.6 → 3.7 轮</a:t>
+              <a:t>5.6 → 3.8 轮</a:t>
             </a:r>
             <a:endParaRPr lang="en-US" sz="3200" dirty="0"/>
           </a:p>
@@ -30315,7 +30315,7 @@
                 <a:ea typeface="Microsoft YaHei" pitchFamily="34" charset="-122"/>
                 <a:cs typeface="Microsoft YaHei" pitchFamily="34" charset="-120"/>
               </a:rPr>
-              <a:t>−36%</a:t>
+              <a:t>−32%</a:t>
             </a:r>
             <a:endParaRPr lang="en-US" sz="3200" dirty="0"/>
           </a:p>
@@ -31022,7 +31022,7 @@
                 <a:ea typeface="Microsoft YaHei" pitchFamily="34" charset="-122"/>
                 <a:cs typeface="Microsoft YaHei" pitchFamily="34" charset="-120"/>
               </a:rPr>
-              <a:t>ETL 追加状态流水</a:t>
+              <a:t>ETL 追加状态变更行</a:t>
             </a:r>
             <a:endParaRPr lang="en-US" sz="1800" dirty="0"/>
           </a:p>
@@ -32091,7 +32091,7 @@
                 <a:ea typeface="Microsoft YaHei" pitchFamily="34" charset="-122"/>
                 <a:cs typeface="Microsoft YaHei" pitchFamily="34" charset="-120"/>
               </a:rPr>
-              <a:t>645 个错误答案</a:t>
+              <a:t>629 个错误答案</a:t>
             </a:r>
             <a:endParaRPr lang="en-US" sz="1700" dirty="0"/>
           </a:p>
@@ -32133,7 +32133,7 @@
                 <a:ea typeface="Microsoft YaHei" pitchFamily="34" charset="-122"/>
                 <a:cs typeface="Microsoft YaHei" pitchFamily="34" charset="-120"/>
               </a:rPr>
-              <a:t>回放实验，只看结构</a:t>
+              <a:t>回放实验，按模式变更失效</a:t>
             </a:r>
             <a:endParaRPr lang="en-US" sz="1250" dirty="0"/>
           </a:p>
@@ -32311,7 +32311,7 @@
                 <a:ea typeface="Microsoft YaHei" pitchFamily="34" charset="-122"/>
                 <a:cs typeface="Microsoft YaHei" pitchFamily="34" charset="-120"/>
               </a:rPr>
-              <a:t>dbt 式按表测试：不知道哪个口径依赖哪条性质，失败只能整表隔离。</a:t>
+              <a:t>dbt 式按表测试：不知道哪个口径依赖哪条性质，失败只能让整张表上的口径失效。</a:t>
             </a:r>
             <a:endParaRPr lang="en-US" sz="1500" dirty="0"/>
           </a:p>
@@ -32353,7 +32353,7 @@
                 <a:ea typeface="Microsoft YaHei" pitchFamily="34" charset="-122"/>
                 <a:cs typeface="Microsoft YaHei" pitchFamily="34" charset="-120"/>
               </a:rPr>
-              <a:t>少答对 342 题</a:t>
+              <a:t>少答对 177 题</a:t>
             </a:r>
             <a:endParaRPr lang="en-US" sz="1700" dirty="0"/>
           </a:p>
@@ -32919,7 +32919,7 @@
                 <a:ea typeface="Microsoft YaHei" pitchFamily="34" charset="-122"/>
                 <a:cs typeface="Microsoft YaHei" pitchFamily="34" charset="-120"/>
               </a:rPr>
-              <a:t>系统维护时为 73%</a:t>
+              <a:t>系统维护时为 74%</a:t>
             </a:r>
             <a:endParaRPr lang="en-US" sz="1250" dirty="0"/>
           </a:p>
@@ -33700,7 +33700,7 @@
                 <a:ea typeface="Microsoft YaHei" pitchFamily="34" charset="-122"/>
                 <a:cs typeface="Microsoft YaHei" pitchFamily="34" charset="-120"/>
               </a:rPr>
-              <a:t>结论按数据版本保存</a:t>
+              <a:t>检查结果按数据版本保存</a:t>
             </a:r>
             <a:endParaRPr lang="en-US" sz="1550" dirty="0"/>
           </a:p>
@@ -34304,7 +34304,7 @@
                 <a:ea typeface="Microsoft YaHei" pitchFamily="34" charset="-122"/>
                 <a:cs typeface="Microsoft YaHei" pitchFamily="34" charset="-120"/>
               </a:rPr>
-              <a:t>否则撤下口径</a:t>
+              <a:t>否则让口径失效</a:t>
             </a:r>
             <a:endParaRPr lang="en-US" sz="1550" dirty="0"/>
           </a:p>
@@ -34484,7 +34484,7 @@
                 <a:ea typeface="Microsoft YaHei" pitchFamily="34" charset="-122"/>
                 <a:cs typeface="Microsoft YaHei" pitchFamily="34" charset="-120"/>
               </a:rPr>
-              <a:t>对应论文的三项贡献：条件与充分性命题、绑定快照的执行与复用引理、有界修复算法。</a:t>
+              <a:t>对应论文的三项贡献：条件与充分性命题、同快照验证与复用引理、有界修复算法。</a:t>
             </a:r>
             <a:endParaRPr lang="en-US" sz="1600" dirty="0"/>
           </a:p>
@@ -35600,7 +35600,7 @@
                           <a:ea typeface="Microsoft YaHei" pitchFamily="34" charset="-122"/>
                           <a:cs typeface="Microsoft YaHei" pitchFamily="34" charset="-120"/>
                         </a:rPr>
-                        <a:t>时间角色</a:t>
+                        <a:t>日期角色</a:t>
                       </a:r>
                       <a:endParaRPr lang="en-US" sz="1450" dirty="0">
                         <a:latin typeface="Microsoft YaHei" charset="0"/>
@@ -35874,7 +35874,7 @@
                           <a:ea typeface="Microsoft YaHei" pitchFamily="34" charset="-122"/>
                           <a:cs typeface="Microsoft YaHei" pitchFamily="34" charset="-120"/>
                         </a:rPr>
-                        <a:t>日期覆盖</a:t>
+                        <a:t>日期键完整性</a:t>
                       </a:r>
                       <a:endParaRPr lang="en-US" sz="1450" dirty="0">
                         <a:latin typeface="Microsoft YaHei" charset="0"/>
@@ -36239,7 +36239,7 @@
                 <a:ea typeface="Microsoft YaHei" pitchFamily="34" charset="-122"/>
                 <a:cs typeface="Microsoft YaHei" pitchFamily="34" charset="-120"/>
               </a:rPr>
-              <a:t>在业务前提下，四类条件成立 ⇒ 规范 SQL 把每笔业务事件在其期间恰好计数一次，遗漏仅限覆盖条件约束的部分。</a:t>
+              <a:t>在业务前提下，四类条件成立 ⇒ 规范 SQL 把每笔业务事件在其期间恰好计数一次，遗漏仅限完整性条件约束的部分。</a:t>
             </a:r>
             <a:endParaRPr lang="en-US" sz="1500" dirty="0"/>
           </a:p>

</xml_diff>

<commit_message>
Deck for 10-12: appendix A2 shows the learning-snapshot regression (933 vs 780, TPC-DS 630 vs 360)
Co-Authored-By: Claude Opus 5.5 <noreply@anthropic.com>
</commit_message>
<xml_diff>
--- a/docs/mavra-report-2026-10-12.pptx
+++ b/docs/mavra-report-2026-10-12.pptx
@@ -1778,7 +1778,7 @@
           <a:p>
             <a:r>
               <a:rPr lang="en-US" dirty="0"/>
-              <a:t>条件不成立时，有两种结局：修好，或让它失效。修复只做一件事：在低基数列上找一个等值过滤。三道关：过滤后要恢复“一键一行”而且不丢任何业务键；候选过滤必须恰好一个；再通过准入检查和用学习题做的回归测试。用两个例子说明为什么要“唯一”：状态变更行的例子里，“状态=完成”是唯一能恢复粒度的过滤，修复成功；备份副本的例子里，“来源=主库”和“来源=备份”都能恢复粒度，结构上分不出哪个是真实业务数据，所以让它失效。宁可不可用，也不发布可能错的修复。
+              <a:t>条件不成立时，有两种结局：修好，或让它失效。修复只做一件事：在低基数列上找一个等值过滤。三道关：过滤后要恢复“一键一行”而且不丢任何业务键；候选过滤必须恰好一个；再通过准入检查，并在学习时快照上用学习题做回归测试。用两个例子说明为什么要“唯一”：状态变更行的例子里，“状态=完成”是唯一能恢复粒度的过滤，修复成功；备份副本的例子里，“来源=主库”和“来源=备份”都能恢复粒度，结构上分不出哪个是真实业务数据，所以让它失效。宁可不可用，也不发布可能错的修复。
 依据：论文 §5.3；算法 1；§7.4
 报告日期：2026-10-12。内容对应当前 overleaf/ 正文；归档结果单独标注。</a:t>
             </a:r>
@@ -2048,7 +2048,7 @@
           <a:p>
             <a:r>
               <a:rPr lang="en-US" dirty="0"/>
-              <a:t>定义库回放把同一个口径库放在不同维护方式下经历同样的变化，所以差异只来自维护；所有方法都用智能体自己的学习 SQL 作回归对照。在条件能发现的变化下，MAVRA 没有给出任何错误答案，按模式变更失效给出 629 个；真实 TPC-DS 数据上是 0 对 437。dbt 式的表级测试也能让被破坏的口径失效，但不会修，少答对 177 题。条件级、定义级和检查结果缓存三种重验方式逐题答案完全一样，说明端到端里它们的差异来自学到的库而不是维护。图里的 99 个错误全部来自单位换算这个对照，它不违反任何条件，论文明确把它划在边界之外。
+              <a:t>定义库回放把同一个口径库放在不同维护方式下经历同样的变化，所以差异只来自维护；所有方法都用智能体自己的学习 SQL 作回归对照，在学习时快照上比较。在条件能发现的变化下，MAVRA 没有给出任何错误答案，按模式变更失效给出 629 个；真实 TPC-DS 数据上是 0 对 437。dbt 式的表级测试也能让被破坏的口径失效，但不会修，少答对 330 题。条件级、定义级和检查结果缓存三种重验方式逐题答案完全一样，说明端到端里它们的差异来自学到的库而不是维护。图里的 99 个错误全部来自单位换算这个对照，它不违反任何条件，论文明确把它划在边界之外。
 依据：论文 §7.2；gen/review.tex；图 4
 报告日期：2026-10-12。内容对应当前 overleaf/ 正文；归档结果单独标注。</a:t>
             </a:r>
@@ -2948,8 +2948,8 @@
           <a:p>
             <a:r>
               <a:rPr lang="en-US" dirty="0"/>
-              <a:t>问答备用。MAVRA 用智能体自己的学习 SQL 作回归对照，这是部署中一定有的。换成知道区分列的标准答案 SQL 后，同一批 1,470 道题多答对 153 道，全部是多版本更正和缓慢变化维下被拒绝、因而失效的修复，没有一道题因此答错；端到端下两种配置 74% 对 73%，因为口径失效后智能体会自己重新推出过滤。备份副本反例：不要求候选唯一时，一个预见来源列的参照会让错误修复发布，4 道新题错 2 道；要求唯一后两种参照都让口径失效。修复进行中到达的请求与正在进行的修复合并，同时到达的不可用从 63 降到 0。
-依据：论文 §7.4；gen/review.tex、scen-ds.tex
+              <a:t>问答备用。智能体的学习 SQL 只在学习时的那份数据上被判过对。MAVRA 把它和修复后的定义放在学习时快照上比较（数仓用 time travel，原型在准入时复制相关表）：同一批 1,470 道题答对 933 道，多版本更正 168/168、缓慢变化维 63/66 全部修好。同样的测试放在当前数据上只答对 780 道：多版本更正之后智能体的 SQL 会把旧版本也算进去，正确的修复也被拒绝。预先写入区分列的标准答案 SQL 答对 933 道。TPC-DS 上是 630 对 360（共 981 道）。端到端实验早于这个改动，G8 在当前数据上比较，口径失效后智能体自己推出过滤，正确率 74%。备份副本反例：不要求候选唯一时，一个预见来源列的参照会让错误修复发布；要求唯一后都让口径失效。
+依据：论文 §5.3、§7.4；gen/review.tex
 报告日期：2026-10-12。内容对应当前 overleaf/ 正文；归档结果单独标注。</a:t>
             </a:r>
             <a:endParaRPr lang="en-US" dirty="0"/>
@@ -3668,7 +3668,7 @@
           <a:p>
             <a:r>
               <a:rPr lang="en-US" dirty="0"/>
-              <a:t>听众可能会问：数据库和数据工程不是早有一套工具吗？四条路逐一说明。按表结构跟踪变化：表没变，什么也看不到，回放实验里按模式变更失效给出 629 个错误答案。dbt 式的数据测试：按表测，不知道哪个口径依赖哪条性质，测试一失败只能让整张表上的定义全部失效，少答对 177 题。指标层：Databricks 的文档明确写了声明的连接性质“不在运行时验证”。让智能体自己查：轨迹里只有 16% 的会话会检查键唯一性；就算提示它去查，破坏性变化下也只从 57% 提到 63%，而由系统维护是 74%。
+              <a:t>听众可能会问：数据库和数据工程不是早有一套工具吗？四条路逐一说明。按表结构跟踪变化：表没变，什么也看不到，回放实验里按模式变更失效给出 629 个错误答案。dbt 式的数据测试：按表测，不知道哪个口径依赖哪条性质，测试一失败只能让整张表上的定义全部失效，少答对 330 题。指标层：Databricks 的文档明确写了声明的连接性质“不在运行时验证”。让智能体自己查：轨迹里只有 16% 的会话会检查键唯一性；就算提示它去查，破坏性变化下也只从 57% 提到 63%，而由系统维护是 74%。
 依据：论文 §1、§2.4、§7.2、§7.6；gen/review.tex、scen-ds.tex
 报告日期：2026-10-12。内容对应当前 overleaf/ 正文；归档结果单独标注。</a:t>
             </a:r>
@@ -7951,7 +7951,7 @@
                 <a:ea typeface="Microsoft YaHei" pitchFamily="34" charset="-122"/>
                 <a:cs typeface="Microsoft YaHei" pitchFamily="34" charset="-120"/>
               </a:rPr>
-              <a:t>用学习题比对数值</a:t>
+              <a:t>在学习时快照上比对数值</a:t>
             </a:r>
             <a:endParaRPr lang="en-US" sz="1500" dirty="0"/>
           </a:p>
@@ -11376,7 +11376,7 @@
                           <a:ea typeface="Microsoft YaHei" pitchFamily="34" charset="-122"/>
                           <a:cs typeface="Microsoft YaHei" pitchFamily="34" charset="-120"/>
                         </a:rPr>
-                        <a:t>780</a:t>
+                        <a:t>933</a:t>
                       </a:r>
                       <a:endParaRPr lang="en-US" sz="1500" dirty="0">
                         <a:latin typeface="Microsoft YaHei" charset="0"/>
@@ -11650,7 +11650,7 @@
                           <a:ea typeface="Microsoft YaHei" pitchFamily="34" charset="-122"/>
                           <a:cs typeface="Microsoft YaHei" pitchFamily="34" charset="-120"/>
                         </a:rPr>
-                        <a:t>780</a:t>
+                        <a:t>933</a:t>
                       </a:r>
                       <a:endParaRPr lang="en-US" sz="1500" dirty="0">
                         <a:latin typeface="Microsoft YaHei" charset="0"/>
@@ -12155,7 +12155,7 @@
                 <a:ea typeface="Microsoft YaHei" pitchFamily="34" charset="-122"/>
                 <a:cs typeface="Microsoft YaHei" pitchFamily="34" charset="-120"/>
               </a:rPr>
-              <a:t>表级测试也能让被破坏的口径失效，但不会修：MAVRA 多答对 177 题，来自修复或口径自带的过滤。</a:t>
+              <a:t>表级测试也能让被破坏的口径失效，但不会修：MAVRA 多答对 330 题，来自修复或口径自带的过滤。</a:t>
             </a:r>
             <a:endParaRPr lang="en-US" sz="1600" dirty="0"/>
           </a:p>
@@ -20576,7 +20576,7 @@
                 <a:ea typeface="Microsoft YaHei" pitchFamily="34" charset="-122"/>
                 <a:cs typeface="Microsoft YaHei" pitchFamily="34" charset="-120"/>
               </a:rPr>
-              <a:t>粒度条件失效 → 在低基数列上枚举等值过滤 → 保留恢复一键一行且不丢业务键的候选 → 候选恰好一个 → 通过准入检查 G3–G5 与回归 G8 → 发布新修订；任一步失败则让口径失效。</a:t>
+              <a:t>粒度条件失效 → 在低基数列上枚举等值过滤 → 保留恢复一键一行且不丢业务键的候选 → 候选恰好一个 → 通过准入检查 G3–G5 与学习时快照上的回归 G8 → 发布新修订；任一步失败则让口径失效。</a:t>
             </a:r>
             <a:endParaRPr lang="en-US" sz="1350" dirty="0"/>
           </a:p>
@@ -20761,7 +20761,7 @@
                 <a:ea typeface="Microsoft YaHei" pitchFamily="34" charset="-122"/>
                 <a:cs typeface="Microsoft YaHei" pitchFamily="34" charset="-120"/>
               </a:rPr>
-              <a:t>回归对照决定修复能自动完成多少，唯一性规则挡住歧义</a:t>
+              <a:t>回归测试放在学习时快照上做：不需要标准答案也能修好</a:t>
             </a:r>
             <a:endParaRPr lang="en-US" sz="2700" dirty="0"/>
           </a:p>
@@ -20845,7 +20845,7 @@
                 <a:ea typeface="Microsoft YaHei" pitchFamily="34" charset="-122"/>
                 <a:cs typeface="Microsoft YaHei" pitchFamily="34" charset="-120"/>
               </a:rPr>
-              <a:t>论文 §7.4；gen/review.tex、scen-ds.tex</a:t>
+              <a:t>论文 §5.3、§7.4；gen/review.tex</a:t>
             </a:r>
             <a:endParaRPr lang="en-US" sz="850" dirty="0"/>
           </a:p>
@@ -20917,10 +20917,10 @@
               <a:tblPr/>
               <a:tblGrid>
                 <a:gridCol w="4206240"/>
+                <a:gridCol w="3566160"/>
                 <a:gridCol w="3291840"/>
-                <a:gridCol w="3566160"/>
               </a:tblGrid>
-              <a:tr h="566928">
+              <a:tr h="512064">
                 <a:tc>
                   <a:txBody>
                     <a:bodyPr/>
@@ -20938,7 +20938,7 @@
                           <a:ea typeface="Microsoft YaHei" pitchFamily="34" charset="-122"/>
                           <a:cs typeface="Microsoft YaHei" pitchFamily="34" charset="-120"/>
                         </a:rPr>
-                        <a:t>同一批题</a:t>
+                        <a:t>同一批题：答对</a:t>
                       </a:r>
                       <a:endParaRPr lang="en-US" sz="1550" dirty="0">
                         <a:latin typeface="Microsoft YaHei" charset="0"/>
@@ -21006,7 +21006,7 @@
                           <a:ea typeface="Microsoft YaHei" pitchFamily="34" charset="-122"/>
                           <a:cs typeface="Microsoft YaHei" pitchFamily="34" charset="-120"/>
                         </a:rPr>
-                        <a:t>MAVRA（智能体自己的 SQL）</a:t>
+                        <a:t>G8 在学习时快照上（MAVRA）</a:t>
                       </a:r>
                       <a:endParaRPr lang="en-US" sz="1550" dirty="0">
                         <a:latin typeface="Microsoft YaHei" charset="0"/>
@@ -21074,7 +21074,7 @@
                           <a:ea typeface="Microsoft YaHei" pitchFamily="34" charset="-122"/>
                           <a:cs typeface="Microsoft YaHei" pitchFamily="34" charset="-120"/>
                         </a:rPr>
-                        <a:t>MAVRA（标准答案 SQL）</a:t>
+                        <a:t>G8 在当前数据上</a:t>
                       </a:r>
                       <a:endParaRPr lang="en-US" sz="1550" dirty="0">
                         <a:latin typeface="Microsoft YaHei" charset="0"/>
@@ -21126,7 +21126,7 @@
                   </a:tcPr>
                 </a:tc>
               </a:tr>
-              <a:tr h="566928">
+              <a:tr h="512064">
                 <a:tc>
                   <a:txBody>
                     <a:bodyPr/>
@@ -21144,7 +21144,75 @@
                           <a:ea typeface="Microsoft YaHei" pitchFamily="34" charset="-122"/>
                           <a:cs typeface="Microsoft YaHei" pitchFamily="34" charset="-120"/>
                         </a:rPr>
-                        <a:t>1,470 道题：答对</a:t>
+                        <a:t>定义库回放（1,470 道）</a:t>
+                      </a:r>
+                      <a:endParaRPr lang="en-US" sz="1550" dirty="0">
+                        <a:latin typeface="Microsoft YaHei" charset="0"/>
+                        <a:ea typeface="Microsoft YaHei" charset="0"/>
+                        <a:cs typeface="Microsoft YaHei" charset="0"/>
+                      </a:endParaRPr>
+                    </a:p>
+                  </a:txBody>
+                  <a:tcPr marL="77724" marR="77724" marT="41148" marB="41148" anchor="ctr">
+                    <a:lnL w="15240" cap="flat" cmpd="sng" algn="ctr">
+                      <a:solidFill>
+                        <a:srgbClr val="FFFFFF"/>
+                      </a:solidFill>
+                      <a:prstDash val="solid"/>
+                      <a:round/>
+                      <a:headEnd type="none" w="med" len="med"/>
+                      <a:tailEnd type="none" w="med" len="med"/>
+                    </a:lnL>
+                    <a:lnR w="15240" cap="flat" cmpd="sng" algn="ctr">
+                      <a:solidFill>
+                        <a:srgbClr val="FFFFFF"/>
+                      </a:solidFill>
+                      <a:prstDash val="solid"/>
+                      <a:round/>
+                      <a:headEnd type="none" w="med" len="med"/>
+                      <a:tailEnd type="none" w="med" len="med"/>
+                    </a:lnR>
+                    <a:lnT w="15240" cap="flat" cmpd="sng" algn="ctr">
+                      <a:solidFill>
+                        <a:srgbClr val="FFFFFF"/>
+                      </a:solidFill>
+                      <a:prstDash val="solid"/>
+                      <a:round/>
+                      <a:headEnd type="none" w="med" len="med"/>
+                      <a:tailEnd type="none" w="med" len="med"/>
+                    </a:lnT>
+                    <a:lnB w="15240" cap="flat" cmpd="sng" algn="ctr">
+                      <a:solidFill>
+                        <a:srgbClr val="FFFFFF"/>
+                      </a:solidFill>
+                      <a:prstDash val="solid"/>
+                      <a:round/>
+                      <a:headEnd type="none" w="med" len="med"/>
+                      <a:tailEnd type="none" w="med" len="med"/>
+                    </a:lnB>
+                    <a:solidFill>
+                      <a:srgbClr val="FFFFFF"/>
+                    </a:solidFill>
+                  </a:tcPr>
+                </a:tc>
+                <a:tc>
+                  <a:txBody>
+                    <a:bodyPr/>
+                    <a:lstStyle/>
+                    <a:p>
+                      <a:pPr algn="r" indent="0" marL="0">
+                        <a:buNone/>
+                      </a:pPr>
+                      <a:r>
+                        <a:rPr lang="en-US" sz="1550" dirty="0">
+                          <a:solidFill>
+                            <a:srgbClr val="24364D"/>
+                          </a:solidFill>
+                          <a:latin typeface="Microsoft YaHei" pitchFamily="34" charset="0"/>
+                          <a:ea typeface="Microsoft YaHei" pitchFamily="34" charset="-122"/>
+                          <a:cs typeface="Microsoft YaHei" pitchFamily="34" charset="-120"/>
+                        </a:rPr>
+                        <a:t>933</a:t>
                       </a:r>
                       <a:endParaRPr lang="en-US" sz="1550" dirty="0">
                         <a:latin typeface="Microsoft YaHei" charset="0"/>
@@ -21263,76 +21331,8 @@
                     </a:solidFill>
                   </a:tcPr>
                 </a:tc>
-                <a:tc>
-                  <a:txBody>
-                    <a:bodyPr/>
-                    <a:lstStyle/>
-                    <a:p>
-                      <a:pPr algn="r" indent="0" marL="0">
-                        <a:buNone/>
-                      </a:pPr>
-                      <a:r>
-                        <a:rPr lang="en-US" sz="1550" dirty="0">
-                          <a:solidFill>
-                            <a:srgbClr val="24364D"/>
-                          </a:solidFill>
-                          <a:latin typeface="Microsoft YaHei" pitchFamily="34" charset="0"/>
-                          <a:ea typeface="Microsoft YaHei" pitchFamily="34" charset="-122"/>
-                          <a:cs typeface="Microsoft YaHei" pitchFamily="34" charset="-120"/>
-                        </a:rPr>
-                        <a:t>933</a:t>
-                      </a:r>
-                      <a:endParaRPr lang="en-US" sz="1550" dirty="0">
-                        <a:latin typeface="Microsoft YaHei" charset="0"/>
-                        <a:ea typeface="Microsoft YaHei" charset="0"/>
-                        <a:cs typeface="Microsoft YaHei" charset="0"/>
-                      </a:endParaRPr>
-                    </a:p>
-                  </a:txBody>
-                  <a:tcPr marL="77724" marR="77724" marT="41148" marB="41148" anchor="ctr">
-                    <a:lnL w="15240" cap="flat" cmpd="sng" algn="ctr">
-                      <a:solidFill>
-                        <a:srgbClr val="FFFFFF"/>
-                      </a:solidFill>
-                      <a:prstDash val="solid"/>
-                      <a:round/>
-                      <a:headEnd type="none" w="med" len="med"/>
-                      <a:tailEnd type="none" w="med" len="med"/>
-                    </a:lnL>
-                    <a:lnR w="15240" cap="flat" cmpd="sng" algn="ctr">
-                      <a:solidFill>
-                        <a:srgbClr val="FFFFFF"/>
-                      </a:solidFill>
-                      <a:prstDash val="solid"/>
-                      <a:round/>
-                      <a:headEnd type="none" w="med" len="med"/>
-                      <a:tailEnd type="none" w="med" len="med"/>
-                    </a:lnR>
-                    <a:lnT w="15240" cap="flat" cmpd="sng" algn="ctr">
-                      <a:solidFill>
-                        <a:srgbClr val="FFFFFF"/>
-                      </a:solidFill>
-                      <a:prstDash val="solid"/>
-                      <a:round/>
-                      <a:headEnd type="none" w="med" len="med"/>
-                      <a:tailEnd type="none" w="med" len="med"/>
-                    </a:lnT>
-                    <a:lnB w="15240" cap="flat" cmpd="sng" algn="ctr">
-                      <a:solidFill>
-                        <a:srgbClr val="FFFFFF"/>
-                      </a:solidFill>
-                      <a:prstDash val="solid"/>
-                      <a:round/>
-                      <a:headEnd type="none" w="med" len="med"/>
-                      <a:tailEnd type="none" w="med" len="med"/>
-                    </a:lnB>
-                    <a:solidFill>
-                      <a:srgbClr val="FFFFFF"/>
-                    </a:solidFill>
-                  </a:tcPr>
-                </a:tc>
               </a:tr>
-              <a:tr h="566928">
+              <a:tr h="512064">
                 <a:tc>
                   <a:txBody>
                     <a:bodyPr/>
@@ -21350,7 +21350,7 @@
                           <a:ea typeface="Microsoft YaHei" pitchFamily="34" charset="-122"/>
                           <a:cs typeface="Microsoft YaHei" pitchFamily="34" charset="-120"/>
                         </a:rPr>
-                        <a:t>自动发布的修复（端到端，每次运行）</a:t>
+                        <a:t>其中：多版本更正</a:t>
                       </a:r>
                       <a:endParaRPr lang="en-US" sz="1550" dirty="0">
                         <a:latin typeface="Microsoft YaHei" charset="0"/>
@@ -21418,7 +21418,7 @@
                           <a:ea typeface="Microsoft YaHei" pitchFamily="34" charset="-122"/>
                           <a:cs typeface="Microsoft YaHei" pitchFamily="34" charset="-120"/>
                         </a:rPr>
-                        <a:t>4.7</a:t>
+                        <a:t>168/168</a:t>
                       </a:r>
                       <a:endParaRPr lang="en-US" sz="1550" dirty="0">
                         <a:latin typeface="Microsoft YaHei" charset="0"/>
@@ -21486,7 +21486,7 @@
                           <a:ea typeface="Microsoft YaHei" pitchFamily="34" charset="-122"/>
                           <a:cs typeface="Microsoft YaHei" pitchFamily="34" charset="-120"/>
                         </a:rPr>
-                        <a:t>8.0</a:t>
+                        <a:t>69/168</a:t>
                       </a:r>
                       <a:endParaRPr lang="en-US" sz="1550" dirty="0">
                         <a:latin typeface="Microsoft YaHei" charset="0"/>
@@ -21538,7 +21538,7 @@
                   </a:tcPr>
                 </a:tc>
               </a:tr>
-              <a:tr h="566928">
+              <a:tr h="512064">
                 <a:tc>
                   <a:txBody>
                     <a:bodyPr/>
@@ -21556,7 +21556,7 @@
                           <a:ea typeface="Microsoft YaHei" pitchFamily="34" charset="-122"/>
                           <a:cs typeface="Microsoft YaHei" pitchFamily="34" charset="-120"/>
                         </a:rPr>
-                        <a:t>端到端：破坏性变化下正确率</a:t>
+                        <a:t>其中：缓慢变化维</a:t>
                       </a:r>
                       <a:endParaRPr lang="en-US" sz="1550" dirty="0">
                         <a:latin typeface="Microsoft YaHei" charset="0"/>
@@ -21624,7 +21624,7 @@
                           <a:ea typeface="Microsoft YaHei" pitchFamily="34" charset="-122"/>
                           <a:cs typeface="Microsoft YaHei" pitchFamily="34" charset="-120"/>
                         </a:rPr>
-                        <a:t>74%</a:t>
+                        <a:t>63/66</a:t>
                       </a:r>
                       <a:endParaRPr lang="en-US" sz="1550" dirty="0">
                         <a:latin typeface="Microsoft YaHei" charset="0"/>
@@ -21692,7 +21692,7 @@
                           <a:ea typeface="Microsoft YaHei" pitchFamily="34" charset="-122"/>
                           <a:cs typeface="Microsoft YaHei" pitchFamily="34" charset="-120"/>
                         </a:rPr>
-                        <a:t>73%</a:t>
+                        <a:t>9/66</a:t>
                       </a:r>
                       <a:endParaRPr lang="en-US" sz="1550" dirty="0">
                         <a:latin typeface="Microsoft YaHei" charset="0"/>
@@ -21744,6 +21744,212 @@
                   </a:tcPr>
                 </a:tc>
               </a:tr>
+              <a:tr h="512064">
+                <a:tc>
+                  <a:txBody>
+                    <a:bodyPr/>
+                    <a:lstStyle/>
+                    <a:p>
+                      <a:pPr algn="l" indent="0" marL="0">
+                        <a:buNone/>
+                      </a:pPr>
+                      <a:r>
+                        <a:rPr lang="en-US" sz="1550" dirty="0">
+                          <a:solidFill>
+                            <a:srgbClr val="24364D"/>
+                          </a:solidFill>
+                          <a:latin typeface="Microsoft YaHei" pitchFamily="34" charset="0"/>
+                          <a:ea typeface="Microsoft YaHei" pitchFamily="34" charset="-122"/>
+                          <a:cs typeface="Microsoft YaHei" pitchFamily="34" charset="-120"/>
+                        </a:rPr>
+                        <a:t>TPC-DS（981 道）</a:t>
+                      </a:r>
+                      <a:endParaRPr lang="en-US" sz="1550" dirty="0">
+                        <a:latin typeface="Microsoft YaHei" charset="0"/>
+                        <a:ea typeface="Microsoft YaHei" charset="0"/>
+                        <a:cs typeface="Microsoft YaHei" charset="0"/>
+                      </a:endParaRPr>
+                    </a:p>
+                  </a:txBody>
+                  <a:tcPr marL="77724" marR="77724" marT="41148" marB="41148" anchor="ctr">
+                    <a:lnL w="15240" cap="flat" cmpd="sng" algn="ctr">
+                      <a:solidFill>
+                        <a:srgbClr val="FFFFFF"/>
+                      </a:solidFill>
+                      <a:prstDash val="solid"/>
+                      <a:round/>
+                      <a:headEnd type="none" w="med" len="med"/>
+                      <a:tailEnd type="none" w="med" len="med"/>
+                    </a:lnL>
+                    <a:lnR w="15240" cap="flat" cmpd="sng" algn="ctr">
+                      <a:solidFill>
+                        <a:srgbClr val="FFFFFF"/>
+                      </a:solidFill>
+                      <a:prstDash val="solid"/>
+                      <a:round/>
+                      <a:headEnd type="none" w="med" len="med"/>
+                      <a:tailEnd type="none" w="med" len="med"/>
+                    </a:lnR>
+                    <a:lnT w="15240" cap="flat" cmpd="sng" algn="ctr">
+                      <a:solidFill>
+                        <a:srgbClr val="FFFFFF"/>
+                      </a:solidFill>
+                      <a:prstDash val="solid"/>
+                      <a:round/>
+                      <a:headEnd type="none" w="med" len="med"/>
+                      <a:tailEnd type="none" w="med" len="med"/>
+                    </a:lnT>
+                    <a:lnB w="15240" cap="flat" cmpd="sng" algn="ctr">
+                      <a:solidFill>
+                        <a:srgbClr val="FFFFFF"/>
+                      </a:solidFill>
+                      <a:prstDash val="solid"/>
+                      <a:round/>
+                      <a:headEnd type="none" w="med" len="med"/>
+                      <a:tailEnd type="none" w="med" len="med"/>
+                    </a:lnB>
+                    <a:solidFill>
+                      <a:srgbClr val="EEF2F7"/>
+                    </a:solidFill>
+                  </a:tcPr>
+                </a:tc>
+                <a:tc>
+                  <a:txBody>
+                    <a:bodyPr/>
+                    <a:lstStyle/>
+                    <a:p>
+                      <a:pPr algn="r" indent="0" marL="0">
+                        <a:buNone/>
+                      </a:pPr>
+                      <a:r>
+                        <a:rPr lang="en-US" sz="1550" dirty="0">
+                          <a:solidFill>
+                            <a:srgbClr val="24364D"/>
+                          </a:solidFill>
+                          <a:latin typeface="Microsoft YaHei" pitchFamily="34" charset="0"/>
+                          <a:ea typeface="Microsoft YaHei" pitchFamily="34" charset="-122"/>
+                          <a:cs typeface="Microsoft YaHei" pitchFamily="34" charset="-120"/>
+                        </a:rPr>
+                        <a:t>630</a:t>
+                      </a:r>
+                      <a:endParaRPr lang="en-US" sz="1550" dirty="0">
+                        <a:latin typeface="Microsoft YaHei" charset="0"/>
+                        <a:ea typeface="Microsoft YaHei" charset="0"/>
+                        <a:cs typeface="Microsoft YaHei" charset="0"/>
+                      </a:endParaRPr>
+                    </a:p>
+                  </a:txBody>
+                  <a:tcPr marL="77724" marR="77724" marT="41148" marB="41148" anchor="ctr">
+                    <a:lnL w="15240" cap="flat" cmpd="sng" algn="ctr">
+                      <a:solidFill>
+                        <a:srgbClr val="FFFFFF"/>
+                      </a:solidFill>
+                      <a:prstDash val="solid"/>
+                      <a:round/>
+                      <a:headEnd type="none" w="med" len="med"/>
+                      <a:tailEnd type="none" w="med" len="med"/>
+                    </a:lnL>
+                    <a:lnR w="15240" cap="flat" cmpd="sng" algn="ctr">
+                      <a:solidFill>
+                        <a:srgbClr val="FFFFFF"/>
+                      </a:solidFill>
+                      <a:prstDash val="solid"/>
+                      <a:round/>
+                      <a:headEnd type="none" w="med" len="med"/>
+                      <a:tailEnd type="none" w="med" len="med"/>
+                    </a:lnR>
+                    <a:lnT w="15240" cap="flat" cmpd="sng" algn="ctr">
+                      <a:solidFill>
+                        <a:srgbClr val="FFFFFF"/>
+                      </a:solidFill>
+                      <a:prstDash val="solid"/>
+                      <a:round/>
+                      <a:headEnd type="none" w="med" len="med"/>
+                      <a:tailEnd type="none" w="med" len="med"/>
+                    </a:lnT>
+                    <a:lnB w="15240" cap="flat" cmpd="sng" algn="ctr">
+                      <a:solidFill>
+                        <a:srgbClr val="FFFFFF"/>
+                      </a:solidFill>
+                      <a:prstDash val="solid"/>
+                      <a:round/>
+                      <a:headEnd type="none" w="med" len="med"/>
+                      <a:tailEnd type="none" w="med" len="med"/>
+                    </a:lnB>
+                    <a:solidFill>
+                      <a:srgbClr val="EEF2F7"/>
+                    </a:solidFill>
+                  </a:tcPr>
+                </a:tc>
+                <a:tc>
+                  <a:txBody>
+                    <a:bodyPr/>
+                    <a:lstStyle/>
+                    <a:p>
+                      <a:pPr algn="r" indent="0" marL="0">
+                        <a:buNone/>
+                      </a:pPr>
+                      <a:r>
+                        <a:rPr lang="en-US" sz="1550" dirty="0">
+                          <a:solidFill>
+                            <a:srgbClr val="24364D"/>
+                          </a:solidFill>
+                          <a:latin typeface="Microsoft YaHei" pitchFamily="34" charset="0"/>
+                          <a:ea typeface="Microsoft YaHei" pitchFamily="34" charset="-122"/>
+                          <a:cs typeface="Microsoft YaHei" pitchFamily="34" charset="-120"/>
+                        </a:rPr>
+                        <a:t>360</a:t>
+                      </a:r>
+                      <a:endParaRPr lang="en-US" sz="1550" dirty="0">
+                        <a:latin typeface="Microsoft YaHei" charset="0"/>
+                        <a:ea typeface="Microsoft YaHei" charset="0"/>
+                        <a:cs typeface="Microsoft YaHei" charset="0"/>
+                      </a:endParaRPr>
+                    </a:p>
+                  </a:txBody>
+                  <a:tcPr marL="77724" marR="77724" marT="41148" marB="41148" anchor="ctr">
+                    <a:lnL w="15240" cap="flat" cmpd="sng" algn="ctr">
+                      <a:solidFill>
+                        <a:srgbClr val="FFFFFF"/>
+                      </a:solidFill>
+                      <a:prstDash val="solid"/>
+                      <a:round/>
+                      <a:headEnd type="none" w="med" len="med"/>
+                      <a:tailEnd type="none" w="med" len="med"/>
+                    </a:lnL>
+                    <a:lnR w="15240" cap="flat" cmpd="sng" algn="ctr">
+                      <a:solidFill>
+                        <a:srgbClr val="FFFFFF"/>
+                      </a:solidFill>
+                      <a:prstDash val="solid"/>
+                      <a:round/>
+                      <a:headEnd type="none" w="med" len="med"/>
+                      <a:tailEnd type="none" w="med" len="med"/>
+                    </a:lnR>
+                    <a:lnT w="15240" cap="flat" cmpd="sng" algn="ctr">
+                      <a:solidFill>
+                        <a:srgbClr val="FFFFFF"/>
+                      </a:solidFill>
+                      <a:prstDash val="solid"/>
+                      <a:round/>
+                      <a:headEnd type="none" w="med" len="med"/>
+                      <a:tailEnd type="none" w="med" len="med"/>
+                    </a:lnT>
+                    <a:lnB w="15240" cap="flat" cmpd="sng" algn="ctr">
+                      <a:solidFill>
+                        <a:srgbClr val="FFFFFF"/>
+                      </a:solidFill>
+                      <a:prstDash val="solid"/>
+                      <a:round/>
+                      <a:headEnd type="none" w="med" len="med"/>
+                      <a:tailEnd type="none" w="med" len="med"/>
+                    </a:lnB>
+                    <a:solidFill>
+                      <a:srgbClr val="EEF2F7"/>
+                    </a:solidFill>
+                  </a:tcPr>
+                </a:tc>
+              </a:tr>
             </a:tbl>
           </a:graphicData>
         </a:graphic>
@@ -21756,12 +21962,12 @@
         </p:nvSpPr>
         <p:spPr>
           <a:xfrm>
-            <a:off x="548640" y="4069080"/>
-            <a:ext cx="5440680" cy="1554480"/>
+            <a:off x="548640" y="4206240"/>
+            <a:ext cx="5440680" cy="1417320"/>
           </a:xfrm>
           <a:prstGeom prst="roundRect">
             <a:avLst>
-              <a:gd name="adj" fmla="val 5882"/>
+              <a:gd name="adj" fmla="val 6452"/>
             </a:avLst>
           </a:prstGeom>
           <a:solidFill>
@@ -21783,7 +21989,7 @@
         </p:nvSpPr>
         <p:spPr>
           <a:xfrm>
-            <a:off x="768096" y="4288536"/>
+            <a:off x="768096" y="4425696"/>
             <a:ext cx="5038344" cy="420624"/>
           </a:xfrm>
           <a:prstGeom prst="rect">
@@ -21825,8 +22031,8 @@
         </p:nvSpPr>
         <p:spPr>
           <a:xfrm>
-            <a:off x="768096" y="4892040"/>
-            <a:ext cx="5001768" cy="585216"/>
+            <a:off x="768096" y="5029200"/>
+            <a:ext cx="5001768" cy="448056"/>
           </a:xfrm>
           <a:prstGeom prst="rect">
             <a:avLst/>
@@ -21853,7 +22059,7 @@
                 <a:ea typeface="Microsoft YaHei" pitchFamily="34" charset="-122"/>
                 <a:cs typeface="Microsoft YaHei" pitchFamily="34" charset="-120"/>
               </a:rPr>
-              <a:t>不要求候选唯一时可发布错误修复；要求唯一时两种参照均让口径失效。</a:t>
+              <a:t>不要求候选唯一时可发布错误修复；要求唯一时让口径失效。</a:t>
             </a:r>
             <a:endParaRPr lang="en-US" sz="1500" dirty="0"/>
           </a:p>
@@ -21867,12 +22073,12 @@
         </p:nvSpPr>
         <p:spPr>
           <a:xfrm>
-            <a:off x="6172200" y="4069080"/>
-            <a:ext cx="5440680" cy="1554480"/>
+            <a:off x="6172200" y="4206240"/>
+            <a:ext cx="5440680" cy="1417320"/>
           </a:xfrm>
           <a:prstGeom prst="roundRect">
             <a:avLst>
-              <a:gd name="adj" fmla="val 5882"/>
+              <a:gd name="adj" fmla="val 6452"/>
             </a:avLst>
           </a:prstGeom>
           <a:solidFill>
@@ -21894,7 +22100,7 @@
         </p:nvSpPr>
         <p:spPr>
           <a:xfrm>
-            <a:off x="6391656" y="4288536"/>
+            <a:off x="6391656" y="4425696"/>
             <a:ext cx="5038344" cy="420624"/>
           </a:xfrm>
           <a:prstGeom prst="rect">
@@ -21936,8 +22142,8 @@
         </p:nvSpPr>
         <p:spPr>
           <a:xfrm>
-            <a:off x="6391656" y="4892040"/>
-            <a:ext cx="5001768" cy="585216"/>
+            <a:off x="6391656" y="5029200"/>
+            <a:ext cx="5001768" cy="448056"/>
           </a:xfrm>
           <a:prstGeom prst="rect">
             <a:avLst/>
@@ -22033,7 +22239,7 @@
                 <a:ea typeface="Microsoft YaHei" pitchFamily="34" charset="-122"/>
                 <a:cs typeface="Microsoft YaHei" pitchFamily="34" charset="-120"/>
               </a:rPr>
-              <a:t>对照只决定修复能自动完成多少，不决定会不会答错；变化不触及学习期时，智能体自己的 SQL 就够了。</a:t>
+              <a:t>参照只在它被判对的快照上可信；放回那个快照，就不需要标准答案。</a:t>
             </a:r>
             <a:endParaRPr lang="en-US" sz="1600" dirty="0"/>
           </a:p>
@@ -32353,7 +32559,7 @@
                 <a:ea typeface="Microsoft YaHei" pitchFamily="34" charset="-122"/>
                 <a:cs typeface="Microsoft YaHei" pitchFamily="34" charset="-120"/>
               </a:rPr>
-              <a:t>少答对 177 题</a:t>
+              <a:t>少答对 330 题</a:t>
             </a:r>
             <a:endParaRPr lang="en-US" sz="1700" dirty="0"/>
           </a:p>

</xml_diff>

<commit_message>
Deck for 10-12: end-to-end numbers from the reruns (MAVRA with G8 on the learning snapshot)
Co-Authored-By: Claude Opus 5.5 <noreply@anthropic.com>
</commit_message>
<xml_diff>
--- a/docs/mavra-report-2026-10-12.pptx
+++ b/docs/mavra-report-2026-10-12.pptx
@@ -582,10 +582,10 @@
                   <c:v>63</c:v>
                 </c:pt>
                 <c:pt idx="3">
-                  <c:v>59</c:v>
+                  <c:v>58</c:v>
                 </c:pt>
                 <c:pt idx="4">
-                  <c:v>74</c:v>
+                  <c:v>73</c:v>
                 </c:pt>
               </c:numCache>
             </c:numRef>
@@ -2318,7 +2318,7 @@
           <a:p>
             <a:r>
               <a:rPr lang="en-US" dirty="0"/>
-              <a:t>蓝柱是全部情形，橙柱是条件能发现的破坏性变化。先看蓝柱：不共享 32%，共享但不验证 75%，MAVRA 81%，所以共享本身是最大的一步。再看橙柱：破坏性变化下，MAVRA 74%，模仿 AgentSM 的轨迹检索 57%，预先登记的比较差 17 个百分点，95% 区间 15 到 18；让检索的智能体自己检查这些性质，也只到 63%。右下角是一个诚实的反例：备份副本的变化下 MAVRA 让口径失效了，智能体要自己重找，这一组反而输给检索。
+              <a:t>蓝柱是全部情形，橙柱是条件能发现的破坏性变化。先看蓝柱：不共享 32%，共享但不验证 75%，MAVRA 81%，所以共享本身是最大的一步。再看橙柱：破坏性变化下，MAVRA 73%，模仿 AgentSM 的轨迹检索 57%，预先登记的比较差 16 个百分点，95% 区间 11 到 19；让检索的智能体自己检查这些性质，也只到 63%。右下角是一个诚实的反例：备份副本的变化下 MAVRA 让口径失效了，智能体要自己重找，这一组反而输给检索。
 依据：论文 §7.6；gen/scen-ds.tex；9 种方法 × 3 次
 报告日期：2026-10-12。内容对应当前 overleaf/ 正文；归档结果单独标注。</a:t>
             </a:r>
@@ -2498,7 +2498,7 @@
           <a:p>
             <a:r>
               <a:rPr lang="en-US" dirty="0"/>
-              <a:t>这页是给第一次接触这个方向的听众的地图。四个框按“背景—问题—做法—效果”排列，后面每一节都对应其中一个框。三个数字分别来自三组不同实验，不是同一个分母：74% 对 57% 是真实智能体在破坏性数据变化下的最终答案正确率；0 违规是并发写入下的系统层实验；64 秒到 38 秒是固定定义库的会话实验。
+              <a:t>这页是给第一次接触这个方向的听众的地图。四个框按“背景—问题—做法—效果”排列，后面每一节都对应其中一个框。三个数字分别来自三组不同实验，不是同一个分母：73% 对 57% 是真实智能体在破坏性数据变化下的最终答案正确率；0 违规是并发写入下的系统层实验；64 秒到 38 秒是固定定义库的会话实验。
 依据：论文摘要；gen/scen-ds.tex、review.tex、session-latency.tex
 报告日期：2026-10-12。内容对应当前 overleaf/ 正文；归档结果单独标注。</a:t>
             </a:r>
@@ -2948,7 +2948,7 @@
           <a:p>
             <a:r>
               <a:rPr lang="en-US" dirty="0"/>
-              <a:t>问答备用。智能体的学习 SQL 只在学习时的那份数据上被判过对。MAVRA 把它和修复后的定义放在学习时快照上比较（数仓用 time travel，原型在准入时复制相关表）：同一批 1,470 道题答对 933 道，多版本更正 168/168、缓慢变化维 63/66 全部修好。同样的测试放在当前数据上只答对 780 道：多版本更正之后智能体的 SQL 会把旧版本也算进去，正确的修复也被拒绝。预先写入区分列的标准答案 SQL 答对 933 道。TPC-DS 上是 630 对 360（共 981 道）。端到端实验早于这个改动，G8 在当前数据上比较，口径失效后智能体自己推出过滤，正确率 74%。备份副本反例：不要求候选唯一时，一个预见来源列的参照会让错误修复发布；要求唯一后都让口径失效。
+              <a:t>问答备用。智能体的学习 SQL 只在学习时的那份数据上被判过对。MAVRA 把它和修复后的定义放在学习时快照上比较（数仓用 time travel，原型在准入时复制相关表）：同一批 1,470 道题答对 933 道，多版本更正 168/168、缓慢变化维 63/66 全部修好。同样的测试放在当前数据上只答对 780 道：多版本更正之后智能体的 SQL 会把旧版本也算进去，正确的修复也被拒绝。预先写入区分列的标准答案 SQL 答对 933 道。TPC-DS 上是 630 对 360（共 981 道）。端到端：每次运行自动修好 10.3 个，G8 用当前数据时只有 4.7 个；正确率 73% 对 72%，因为口径失效后智能体会自己推出过滤。备份副本反例：不要求候选唯一时，一个预见来源列的参照会让错误修复发布；要求唯一后都让口径失效。
 依据：论文 §5.3、§7.4；gen/review.tex
 报告日期：2026-10-12。内容对应当前 overleaf/ 正文；归档结果单独标注。</a:t>
             </a:r>
@@ -3668,7 +3668,7 @@
           <a:p>
             <a:r>
               <a:rPr lang="en-US" dirty="0"/>
-              <a:t>听众可能会问：数据库和数据工程不是早有一套工具吗？四条路逐一说明。按表结构跟踪变化：表没变，什么也看不到，回放实验里按模式变更失效给出 629 个错误答案。dbt 式的数据测试：按表测，不知道哪个口径依赖哪条性质，测试一失败只能让整张表上的定义全部失效，少答对 330 题。指标层：Databricks 的文档明确写了声明的连接性质“不在运行时验证”。让智能体自己查：轨迹里只有 16% 的会话会检查键唯一性；就算提示它去查，破坏性变化下也只从 57% 提到 63%，而由系统维护是 74%。
+              <a:t>听众可能会问：数据库和数据工程不是早有一套工具吗？四条路逐一说明。按表结构跟踪变化：表没变，什么也看不到，回放实验里按模式变更失效给出 629 个错误答案。dbt 式的数据测试：按表测，不知道哪个口径依赖哪条性质，测试一失败只能让整张表上的定义全部失效，少答对 330 题。指标层：Databricks 的文档明确写了声明的连接性质“不在运行时验证”。让智能体自己查：轨迹里只有 16% 的会话会检查键唯一性；就算提示它去查，破坏性变化下也只从 57% 提到 63%，而由系统维护是 73%。
 依据：论文 §1、§2.4、§7.2、§7.6；gen/review.tex、scen-ds.tex
 报告日期：2026-10-12。内容对应当前 overleaf/ 正文；归档结果单独标注。</a:t>
             </a:r>
@@ -10123,7 +10123,7 @@
                 <a:ea typeface="Microsoft YaHei" pitchFamily="34" charset="-122"/>
                 <a:cs typeface="Microsoft YaHei" pitchFamily="34" charset="-120"/>
               </a:rPr>
-              <a:t>9 种方法 × 3 次独立运行，2586 道计分题；另有 216 个固定库会话量时间与 token</a:t>
+              <a:t>9 种方法 × 3 次独立运行，2878 道计分题；另有 216 个固定库会话量时间与 token</a:t>
             </a:r>
             <a:endParaRPr lang="en-US" sz="1450" dirty="0"/>
           </a:p>
@@ -13859,7 +13859,7 @@
                 <a:ea typeface="Microsoft YaHei" pitchFamily="34" charset="-122"/>
                 <a:cs typeface="Microsoft YaHei" pitchFamily="34" charset="-120"/>
               </a:rPr>
-              <a:t>端到端：共享把正确率从 32% 提到 75%，维护再拉开 17 个点</a:t>
+              <a:t>端到端：共享把正确率从 32% 提到 75%，维护再拉开 16 个点</a:t>
             </a:r>
             <a:endParaRPr lang="en-US" sz="2500" dirty="0"/>
           </a:p>
@@ -14113,7 +14113,7 @@
                 <a:ea typeface="Microsoft YaHei" pitchFamily="34" charset="-122"/>
                 <a:cs typeface="Microsoft YaHei" pitchFamily="34" charset="-120"/>
               </a:rPr>
-              <a:t>破坏性变化：MAVRA 74% vs 轨迹检索 57%；预登记的差 +17（95% 区间 15–18）。</a:t>
+              <a:t>破坏性变化：MAVRA 73% vs 轨迹检索 57%；预登记的差 +16（95% 区间 11–19）。</a:t>
             </a:r>
             <a:endParaRPr lang="en-US" sz="1500" dirty="0"/>
           </a:p>
@@ -14179,7 +14179,7 @@
                 <a:ea typeface="Microsoft YaHei" pitchFamily="34" charset="-122"/>
                 <a:cs typeface="Microsoft YaHei" pitchFamily="34" charset="-120"/>
               </a:rPr>
-              <a:t>反例：备份副本下 MAVRA 让口径失效，这一组 61% 低于检索的 72%。</a:t>
+              <a:t>反例：备份副本下 MAVRA 让口径失效，这一组 56% 低于检索的 72%。</a:t>
             </a:r>
             <a:endParaRPr lang="en-US" sz="1400" dirty="0"/>
           </a:p>
@@ -17697,7 +17697,7 @@
                 <a:ea typeface="Microsoft YaHei" pitchFamily="34" charset="-122"/>
                 <a:cs typeface="Microsoft YaHei" pitchFamily="34" charset="-120"/>
               </a:rPr>
-              <a:t>破坏性数据变化下，智能体正确率 74%，对照的轨迹检索 57%。</a:t>
+              <a:t>破坏性数据变化下，智能体正确率 73%，对照的轨迹检索 57%。</a:t>
             </a:r>
             <a:endParaRPr lang="en-US" sz="1500" dirty="0"/>
           </a:p>
@@ -30437,7 +30437,7 @@
                 <a:ea typeface="Microsoft YaHei" pitchFamily="34" charset="-122"/>
                 <a:cs typeface="Microsoft YaHei" pitchFamily="34" charset="-120"/>
               </a:rPr>
-              <a:t>5.6 → 3.8 轮</a:t>
+              <a:t>5.6 → 3.6 轮</a:t>
             </a:r>
             <a:endParaRPr lang="en-US" sz="3200" dirty="0"/>
           </a:p>
@@ -30521,7 +30521,7 @@
                 <a:ea typeface="Microsoft YaHei" pitchFamily="34" charset="-122"/>
                 <a:cs typeface="Microsoft YaHei" pitchFamily="34" charset="-120"/>
               </a:rPr>
-              <a:t>−32%</a:t>
+              <a:t>−34%</a:t>
             </a:r>
             <a:endParaRPr lang="en-US" sz="3200" dirty="0"/>
           </a:p>
@@ -33125,7 +33125,7 @@
                 <a:ea typeface="Microsoft YaHei" pitchFamily="34" charset="-122"/>
                 <a:cs typeface="Microsoft YaHei" pitchFamily="34" charset="-120"/>
               </a:rPr>
-              <a:t>系统维护时为 74%</a:t>
+              <a:t>系统维护时为 73%</a:t>
             </a:r>
             <a:endParaRPr lang="en-US" sz="1250" dirty="0"/>
           </a:p>

</xml_diff>

<commit_message>
Deck for 10-12: as-of query wording for the regression test
Co-Authored-By: Claude Opus 5.5 <noreply@anthropic.com>
</commit_message>
<xml_diff>
--- a/docs/mavra-report-2026-10-12.pptx
+++ b/docs/mavra-report-2026-10-12.pptx
@@ -1778,7 +1778,7 @@
           <a:p>
             <a:r>
               <a:rPr lang="en-US" dirty="0"/>
-              <a:t>条件不成立时，有两种结局：修好，或让它失效。修复只做一件事：在低基数列上找一个等值过滤。三道关：过滤后要恢复“一键一行”而且不丢任何业务键；候选过滤必须恰好一个；再通过准入检查，并在学习时快照上用学习题做回归测试。用两个例子说明为什么要“唯一”：状态变更行的例子里，“状态=完成”是唯一能恢复粒度的过滤，修复成功；备份副本的例子里，“来源=主库”和“来源=备份”都能恢复粒度，结构上分不出哪个是真实业务数据，所以让它失效。宁可不可用，也不发布可能错的修复。
+              <a:t>条件不成立时，有两种结局：修好，或让它失效。修复只做一件事：在低基数列上找一个等值过滤。三道关：过滤后要恢复“一键一行”而且不丢任何业务键；候选过滤必须恰好一个；再通过准入检查，并按学习时刻作 as-of 查询、用学习题做回归测试。用两个例子说明为什么要“唯一”：状态变更行的例子里，“状态=完成”是唯一能恢复粒度的过滤，修复成功；备份副本的例子里，“来源=主库”和“来源=备份”都能恢复粒度，结构上分不出哪个是真实业务数据，所以让它失效。宁可不可用，也不发布可能错的修复。
 依据：论文 §5.3；算法 1；§7.4
 报告日期：2026-10-12。内容对应当前 overleaf/ 正文；归档结果单独标注。</a:t>
             </a:r>
@@ -2048,7 +2048,7 @@
           <a:p>
             <a:r>
               <a:rPr lang="en-US" dirty="0"/>
-              <a:t>定义库回放把同一个口径库放在不同维护方式下经历同样的变化，所以差异只来自维护；所有方法都用智能体自己的学习 SQL 作回归对照，在学习时快照上比较。在条件能发现的变化下，MAVRA 没有给出任何错误答案，按模式变更失效给出 629 个；真实 TPC-DS 数据上是 0 对 437。dbt 式的表级测试也能让被破坏的口径失效，但不会修，少答对 330 题。条件级、定义级和检查结果缓存三种重验方式逐题答案完全一样，说明端到端里它们的差异来自学到的库而不是维护。图里的 99 个错误全部来自单位换算这个对照，它不违反任何条件，论文明确把它划在边界之外。
+              <a:t>定义库回放把同一个口径库放在不同维护方式下经历同样的变化，所以差异只来自维护；所有方法都用智能体自己的学习 SQL 作回归对照，按学习时刻作 as-of 比较。在条件能发现的变化下，MAVRA 没有给出任何错误答案，按模式变更失效给出 629 个；真实 TPC-DS 数据上是 0 对 437。dbt 式的表级测试也能让被破坏的口径失效，但不会修，少答对 330 题。条件级、定义级和检查结果缓存三种重验方式逐题答案完全一样，说明端到端里它们的差异来自学到的库而不是维护。图里的 99 个错误全部来自单位换算这个对照，它不违反任何条件，论文明确把它划在边界之外。
 依据：论文 §7.2；gen/review.tex；图 4
 报告日期：2026-10-12。内容对应当前 overleaf/ 正文；归档结果单独标注。</a:t>
             </a:r>
@@ -2948,7 +2948,7 @@
           <a:p>
             <a:r>
               <a:rPr lang="en-US" dirty="0"/>
-              <a:t>问答备用。智能体的学习 SQL 只在学习时的那份数据上被判过对。MAVRA 把它和修复后的定义放在学习时快照上比较（数仓用 time travel，原型在准入时复制相关表）：同一批 1,470 道题答对 933 道，多版本更正 168/168、缓慢变化维 63/66 全部修好。同样的测试放在当前数据上只答对 780 道：多版本更正之后智能体的 SQL 会把旧版本也算进去，正确的修复也被拒绝。预先写入区分列的标准答案 SQL 答对 933 道。TPC-DS 上是 630 对 360（共 981 道）。端到端：每次运行自动修好 10.3 个，G8 用当前数据时只有 4.7 个；正确率 73% 对 72%，因为口径失效后智能体会自己推出过滤。备份副本反例：不要求候选唯一时，一个预见来源列的参照会让错误修复发布；要求唯一后都让口径失效。
+              <a:t>问答备用。智能体的学习 SQL 只在学习时的那份数据上被判过对。MAVRA 把它和修复后的定义按学习时刻作 as-of 查询再比较（数仓用 time travel 回答 as-of 查询，原型在准入时保留一份表的副本）：同一批 1,470 道题答对 933 道，多版本更正 168/168、缓慢变化维 63/66 全部修好。同样的测试放在当前数据上只答对 780 道：多版本更正之后智能体的 SQL 会把旧版本也算进去，正确的修复也被拒绝。预先写入区分列的标准答案 SQL 答对 933 道。TPC-DS 上是 630 对 360（共 981 道）。端到端：每次运行自动修好 10.3 个，G8 用当前数据时只有 4.7 个；正确率 73% 对 72%，因为口径失效后智能体会自己推出过滤。备份副本反例：不要求候选唯一时，一个预见来源列的参照会让错误修复发布；要求唯一后都让口径失效。
 依据：论文 §5.3、§7.4；gen/review.tex
 报告日期：2026-10-12。内容对应当前 overleaf/ 正文；归档结果单独标注。</a:t>
             </a:r>
@@ -7951,7 +7951,7 @@
                 <a:ea typeface="Microsoft YaHei" pitchFamily="34" charset="-122"/>
                 <a:cs typeface="Microsoft YaHei" pitchFamily="34" charset="-120"/>
               </a:rPr>
-              <a:t>在学习时快照上比对数值</a:t>
+              <a:t>按学习时刻 as-of 比对数值</a:t>
             </a:r>
             <a:endParaRPr lang="en-US" sz="1500" dirty="0"/>
           </a:p>
@@ -20576,7 +20576,7 @@
                 <a:ea typeface="Microsoft YaHei" pitchFamily="34" charset="-122"/>
                 <a:cs typeface="Microsoft YaHei" pitchFamily="34" charset="-120"/>
               </a:rPr>
-              <a:t>粒度条件失效 → 在低基数列上枚举等值过滤 → 保留恢复一键一行且不丢业务键的候选 → 候选恰好一个 → 通过准入检查 G3–G5 与学习时快照上的回归 G8 → 发布新修订；任一步失败则让口径失效。</a:t>
+              <a:t>粒度条件失效 → 在低基数列上枚举等值过滤 → 保留恢复一键一行且不丢业务键的候选 → 候选恰好一个 → 通过准入检查 G3–G5 与按学习时刻 as-of 的回归 G8 → 发布新修订；任一步失败则让口径失效。</a:t>
             </a:r>
             <a:endParaRPr lang="en-US" sz="1350" dirty="0"/>
           </a:p>
@@ -20753,7 +20753,7 @@
               <a:buNone/>
             </a:pPr>
             <a:r>
-              <a:rPr lang="en-US" sz="2700" b="1" dirty="0">
+              <a:rPr lang="en-US" sz="2500" b="1" dirty="0">
                 <a:solidFill>
                   <a:srgbClr val="1B2A41"/>
                 </a:solidFill>
@@ -20761,9 +20761,9 @@
                 <a:ea typeface="Microsoft YaHei" pitchFamily="34" charset="-122"/>
                 <a:cs typeface="Microsoft YaHei" pitchFamily="34" charset="-120"/>
               </a:rPr>
-              <a:t>回归测试放在学习时快照上做：不需要标准答案也能修好</a:t>
-            </a:r>
-            <a:endParaRPr lang="en-US" sz="2700" dirty="0"/>
+              <a:t>回归测试按学习时刻作 as-of 查询：不需要标准答案也能修好</a:t>
+            </a:r>
+            <a:endParaRPr lang="en-US" sz="2500" dirty="0"/>
           </a:p>
         </p:txBody>
       </p:sp>
@@ -21006,7 +21006,7 @@
                           <a:ea typeface="Microsoft YaHei" pitchFamily="34" charset="-122"/>
                           <a:cs typeface="Microsoft YaHei" pitchFamily="34" charset="-120"/>
                         </a:rPr>
-                        <a:t>G8 在学习时快照上（MAVRA）</a:t>
+                        <a:t>G8 按学习时刻 as-of（MAVRA）</a:t>
                       </a:r>
                       <a:endParaRPr lang="en-US" sz="1550" dirty="0">
                         <a:latin typeface="Microsoft YaHei" charset="0"/>
@@ -22239,7 +22239,7 @@
                 <a:ea typeface="Microsoft YaHei" pitchFamily="34" charset="-122"/>
                 <a:cs typeface="Microsoft YaHei" pitchFamily="34" charset="-120"/>
               </a:rPr>
-              <a:t>参照只在它被判对的快照上可信；放回那个快照，就不需要标准答案。</a:t>
+              <a:t>参照只在它被判对的那个时刻的数据上可信；按那个时刻作 as-of 查询，就不需要标准答案。</a:t>
             </a:r>
             <a:endParaRPr lang="en-US" sz="1600" dirty="0"/>
           </a:p>

</xml_diff>